<commit_message>
clean up and add history
</commit_message>
<xml_diff>
--- a/postprocessing/results/example_atlantic/example_atlantic_results.pptx
+++ b/postprocessing/results/example_atlantic/example_atlantic_results.pptx
@@ -20,6 +20,8 @@
     <p:sldId id="268" r:id="rId18"/>
     <p:sldId id="269" r:id="rId19"/>
     <p:sldId id="270" r:id="rId20"/>
+    <p:sldId id="271" r:id="rId21"/>
+    <p:sldId id="272" r:id="rId22"/>
   </p:sldIdLst>
   <p:sldSz cx="12192000" cy="6858000"/>
   <p:notesSz cx="6858000" cy="9144000"/>
@@ -2584,7 +2586,7 @@
           <a:lstStyle/>
           <a:p>
             <a:r>
-              <a:t>example_atlantic_1</a:t>
+              <a:t>example_atlantic_2</a:t>
             </a:r>
           </a:p>
         </p:txBody>
@@ -2640,7 +2642,7 @@
           <a:lstStyle/>
           <a:p>
             <a:r>
-              <a:t>Full Gantt</a:t>
+              <a:t>Sorted Full Gantt</a:t>
             </a:r>
           </a:p>
         </p:txBody>
@@ -2662,7 +2664,7 @@
         <p:spPr>
           <a:xfrm>
             <a:off x="0" y="566928"/>
-            <a:ext cx="3886200" cy="3876669"/>
+            <a:ext cx="4800600" cy="4848278"/>
           </a:xfrm>
           <a:prstGeom prst="rect">
             <a:avLst/>
@@ -2689,12 +2691,12 @@
       <p:grpSpPr/>
       <p:sp>
         <p:nvSpPr>
-          <p:cNvPr id="2" name="Title 1"/>
+          <p:cNvPr id="2" name="Text Placeholder 1"/>
           <p:cNvSpPr>
             <a:spLocks noGrp="1"/>
           </p:cNvSpPr>
           <p:nvPr>
-            <p:ph type="title"/>
+            <p:ph type="body" idx="10" sz="quarter"/>
           </p:nvPr>
         </p:nvSpPr>
         <p:spPr/>
@@ -2703,35 +2705,28 @@
           <a:lstStyle/>
           <a:p>
             <a:r>
-              <a:t>New England Gantt</a:t>
-            </a:r>
-          </a:p>
-        </p:txBody>
-      </p:sp>
-      <p:pic>
-        <p:nvPicPr>
-          <p:cNvPr id="3" name="Picture 2" descr="image.png"/>
-          <p:cNvPicPr>
-            <a:picLocks noChangeAspect="1"/>
-          </p:cNvPicPr>
-          <p:nvPr/>
-        </p:nvPicPr>
-        <p:blipFill>
-          <a:blip r:embed="rId2"/>
-          <a:stretch>
-            <a:fillRect/>
-          </a:stretch>
-        </p:blipFill>
-        <p:spPr>
-          <a:xfrm>
-            <a:off x="0" y="566928"/>
-            <a:ext cx="12188952" cy="4087025"/>
-          </a:xfrm>
-          <a:prstGeom prst="rect">
-            <a:avLst/>
-          </a:prstGeom>
-        </p:spPr>
-      </p:pic>
+              <a:t>example_atlantic_1</a:t>
+            </a:r>
+          </a:p>
+        </p:txBody>
+      </p:sp>
+      <p:sp>
+        <p:nvSpPr>
+          <p:cNvPr id="3" name="Text Placeholder 2"/>
+          <p:cNvSpPr>
+            <a:spLocks noGrp="1"/>
+          </p:cNvSpPr>
+          <p:nvPr>
+            <p:ph type="body" idx="11" sz="quarter"/>
+          </p:nvPr>
+        </p:nvSpPr>
+        <p:spPr/>
+        <p:txBody>
+          <a:bodyPr/>
+          <a:lstStyle/>
+          <a:p/>
+        </p:txBody>
+      </p:sp>
     </p:spTree>
   </p:cSld>
   <p:clrMapOvr>
@@ -2766,7 +2761,7 @@
           <a:lstStyle/>
           <a:p>
             <a:r>
-              <a:t>Fixed Gantt</a:t>
+              <a:t>Shared Resource Capacity - Vessels</a:t>
             </a:r>
           </a:p>
         </p:txBody>
@@ -2788,7 +2783,7 @@
         <p:spPr>
           <a:xfrm>
             <a:off x="0" y="566928"/>
-            <a:ext cx="12188952" cy="10716712"/>
+            <a:ext cx="3886200" cy="7906543"/>
           </a:xfrm>
           <a:prstGeom prst="rect">
             <a:avLst/>
@@ -2815,12 +2810,12 @@
       <p:grpSpPr/>
       <p:sp>
         <p:nvSpPr>
-          <p:cNvPr id="2" name="Text Placeholder 1"/>
+          <p:cNvPr id="2" name="Title 1"/>
           <p:cNvSpPr>
             <a:spLocks noGrp="1"/>
           </p:cNvSpPr>
           <p:nvPr>
-            <p:ph type="body" idx="10" sz="quarter"/>
+            <p:ph type="title"/>
           </p:nvPr>
         </p:nvSpPr>
         <p:spPr/>
@@ -2829,28 +2824,35 @@
           <a:lstStyle/>
           <a:p>
             <a:r>
-              <a:t>Summary Plots</a:t>
-            </a:r>
-          </a:p>
-        </p:txBody>
-      </p:sp>
-      <p:sp>
-        <p:nvSpPr>
-          <p:cNvPr id="3" name="Text Placeholder 2"/>
-          <p:cNvSpPr>
-            <a:spLocks noGrp="1"/>
-          </p:cNvSpPr>
-          <p:nvPr>
-            <p:ph type="body" idx="11" sz="quarter"/>
-          </p:nvPr>
-        </p:nvSpPr>
-        <p:spPr/>
-        <p:txBody>
-          <a:bodyPr/>
-          <a:lstStyle/>
-          <a:p/>
-        </p:txBody>
-      </p:sp>
+              <a:t>Shared Resource Capacity - Ports</a:t>
+            </a:r>
+          </a:p>
+        </p:txBody>
+      </p:sp>
+      <p:pic>
+        <p:nvPicPr>
+          <p:cNvPr id="3" name="Picture 2" descr="image.png"/>
+          <p:cNvPicPr>
+            <a:picLocks noChangeAspect="1"/>
+          </p:cNvPicPr>
+          <p:nvPr/>
+        </p:nvPicPr>
+        <p:blipFill>
+          <a:blip r:embed="rId2"/>
+          <a:stretch>
+            <a:fillRect/>
+          </a:stretch>
+        </p:blipFill>
+        <p:spPr>
+          <a:xfrm>
+            <a:off x="0" y="566928"/>
+            <a:ext cx="3886200" cy="7906543"/>
+          </a:xfrm>
+          <a:prstGeom prst="rect">
+            <a:avLst/>
+          </a:prstGeom>
+        </p:spPr>
+      </p:pic>
     </p:spTree>
   </p:cSld>
   <p:clrMapOvr>
@@ -2885,7 +2887,7 @@
           <a:lstStyle/>
           <a:p>
             <a:r>
-              <a:t>Cumulative Installed Capacity</a:t>
+              <a:t>Full Gantt</a:t>
             </a:r>
           </a:p>
         </p:txBody>
@@ -2907,7 +2909,7 @@
         <p:spPr>
           <a:xfrm>
             <a:off x="0" y="566928"/>
-            <a:ext cx="12188952" cy="5088381"/>
+            <a:ext cx="3886200" cy="3917501"/>
           </a:xfrm>
           <a:prstGeom prst="rect">
             <a:avLst/>
@@ -2948,7 +2950,7 @@
           <a:lstStyle/>
           <a:p>
             <a:r>
-              <a:t>Summary Installed Capacity</a:t>
+              <a:t>Sorted Full Gantt</a:t>
             </a:r>
           </a:p>
         </p:txBody>
@@ -2970,7 +2972,126 @@
         <p:spPr>
           <a:xfrm>
             <a:off x="0" y="566928"/>
-            <a:ext cx="12188952" cy="8064870"/>
+            <a:ext cx="4800600" cy="4839267"/>
+          </a:xfrm>
+          <a:prstGeom prst="rect">
+            <a:avLst/>
+          </a:prstGeom>
+        </p:spPr>
+      </p:pic>
+    </p:spTree>
+  </p:cSld>
+  <p:clrMapOvr>
+    <a:masterClrMapping/>
+  </p:clrMapOvr>
+</p:sld>
+</file>
+
+<file path=ppt/slides/slide16.xml><?xml version="1.0" encoding="utf-8"?>
+<p:sld xmlns:a="http://schemas.openxmlformats.org/drawingml/2006/main" xmlns:p="http://schemas.openxmlformats.org/presentationml/2006/main" xmlns:r="http://schemas.openxmlformats.org/officeDocument/2006/relationships">
+  <p:cSld>
+    <p:spTree>
+      <p:nvGrpSpPr>
+        <p:cNvPr id="1" name=""/>
+        <p:cNvGrpSpPr/>
+        <p:nvPr/>
+      </p:nvGrpSpPr>
+      <p:grpSpPr/>
+      <p:sp>
+        <p:nvSpPr>
+          <p:cNvPr id="2" name="Text Placeholder 1"/>
+          <p:cNvSpPr>
+            <a:spLocks noGrp="1"/>
+          </p:cNvSpPr>
+          <p:nvPr>
+            <p:ph type="body" idx="10" sz="quarter"/>
+          </p:nvPr>
+        </p:nvSpPr>
+        <p:spPr/>
+        <p:txBody>
+          <a:bodyPr/>
+          <a:lstStyle/>
+          <a:p>
+            <a:r>
+              <a:t>Summary Plots</a:t>
+            </a:r>
+          </a:p>
+        </p:txBody>
+      </p:sp>
+      <p:sp>
+        <p:nvSpPr>
+          <p:cNvPr id="3" name="Text Placeholder 2"/>
+          <p:cNvSpPr>
+            <a:spLocks noGrp="1"/>
+          </p:cNvSpPr>
+          <p:nvPr>
+            <p:ph type="body" idx="11" sz="quarter"/>
+          </p:nvPr>
+        </p:nvSpPr>
+        <p:spPr/>
+        <p:txBody>
+          <a:bodyPr/>
+          <a:lstStyle/>
+          <a:p/>
+        </p:txBody>
+      </p:sp>
+    </p:spTree>
+  </p:cSld>
+  <p:clrMapOvr>
+    <a:masterClrMapping/>
+  </p:clrMapOvr>
+</p:sld>
+</file>
+
+<file path=ppt/slides/slide17.xml><?xml version="1.0" encoding="utf-8"?>
+<p:sld xmlns:a="http://schemas.openxmlformats.org/drawingml/2006/main" xmlns:p="http://schemas.openxmlformats.org/presentationml/2006/main" xmlns:r="http://schemas.openxmlformats.org/officeDocument/2006/relationships">
+  <p:cSld>
+    <p:spTree>
+      <p:nvGrpSpPr>
+        <p:cNvPr id="1" name=""/>
+        <p:cNvGrpSpPr/>
+        <p:nvPr/>
+      </p:nvGrpSpPr>
+      <p:grpSpPr/>
+      <p:sp>
+        <p:nvSpPr>
+          <p:cNvPr id="2" name="Title 1"/>
+          <p:cNvSpPr>
+            <a:spLocks noGrp="1"/>
+          </p:cNvSpPr>
+          <p:nvPr>
+            <p:ph type="title"/>
+          </p:nvPr>
+        </p:nvSpPr>
+        <p:spPr/>
+        <p:txBody>
+          <a:bodyPr/>
+          <a:lstStyle/>
+          <a:p>
+            <a:r>
+              <a:t>Cumulative Installed Capacity</a:t>
+            </a:r>
+          </a:p>
+        </p:txBody>
+      </p:sp>
+      <p:pic>
+        <p:nvPicPr>
+          <p:cNvPr id="3" name="Picture 2" descr="image.png"/>
+          <p:cNvPicPr>
+            <a:picLocks noChangeAspect="1"/>
+          </p:cNvPicPr>
+          <p:nvPr/>
+        </p:nvPicPr>
+        <p:blipFill>
+          <a:blip r:embed="rId2"/>
+          <a:stretch>
+            <a:fillRect/>
+          </a:stretch>
+        </p:blipFill>
+        <p:spPr>
+          <a:xfrm>
+            <a:off x="0" y="566928"/>
+            <a:ext cx="12188952" cy="5091404"/>
           </a:xfrm>
           <a:prstGeom prst="rect">
             <a:avLst/>
@@ -3011,7 +3132,7 @@
           <a:lstStyle/>
           <a:p>
             <a:r>
-              <a:t>Full Gantt</a:t>
+              <a:t>Shared Resource Capacity - Vessels</a:t>
             </a:r>
           </a:p>
         </p:txBody>
@@ -3033,7 +3154,7 @@
         <p:spPr>
           <a:xfrm>
             <a:off x="0" y="566928"/>
-            <a:ext cx="3886200" cy="3924797"/>
+            <a:ext cx="3886200" cy="7906543"/>
           </a:xfrm>
           <a:prstGeom prst="rect">
             <a:avLst/>
@@ -3074,7 +3195,7 @@
           <a:lstStyle/>
           <a:p>
             <a:r>
-              <a:t>New England Gantt</a:t>
+              <a:t>Shared Resource Capacity - Ports</a:t>
             </a:r>
           </a:p>
         </p:txBody>
@@ -3096,7 +3217,7 @@
         <p:spPr>
           <a:xfrm>
             <a:off x="0" y="566928"/>
-            <a:ext cx="12188952" cy="4186105"/>
+            <a:ext cx="3886200" cy="7906543"/>
           </a:xfrm>
           <a:prstGeom prst="rect">
             <a:avLst/>
@@ -3137,7 +3258,7 @@
           <a:lstStyle/>
           <a:p>
             <a:r>
-              <a:t>Fixed Gantt</a:t>
+              <a:t>Full Gantt</a:t>
             </a:r>
           </a:p>
         </p:txBody>
@@ -3159,7 +3280,7 @@
         <p:spPr>
           <a:xfrm>
             <a:off x="0" y="566928"/>
-            <a:ext cx="12188952" cy="10849756"/>
+            <a:ext cx="3886200" cy="3912653"/>
           </a:xfrm>
           <a:prstGeom prst="rect">
             <a:avLst/>
@@ -3186,12 +3307,12 @@
       <p:grpSpPr/>
       <p:sp>
         <p:nvSpPr>
-          <p:cNvPr id="2" name="Text Placeholder 1"/>
+          <p:cNvPr id="2" name="Title 1"/>
           <p:cNvSpPr>
             <a:spLocks noGrp="1"/>
           </p:cNvSpPr>
           <p:nvPr>
-            <p:ph type="body" idx="10" sz="quarter"/>
+            <p:ph type="title"/>
           </p:nvPr>
         </p:nvSpPr>
         <p:spPr/>
@@ -3200,28 +3321,35 @@
           <a:lstStyle/>
           <a:p>
             <a:r>
-              <a:t>example_atlantic_2</a:t>
-            </a:r>
-          </a:p>
-        </p:txBody>
-      </p:sp>
-      <p:sp>
-        <p:nvSpPr>
-          <p:cNvPr id="3" name="Text Placeholder 2"/>
-          <p:cNvSpPr>
-            <a:spLocks noGrp="1"/>
-          </p:cNvSpPr>
-          <p:nvPr>
-            <p:ph type="body" idx="11" sz="quarter"/>
-          </p:nvPr>
-        </p:nvSpPr>
-        <p:spPr/>
-        <p:txBody>
-          <a:bodyPr/>
-          <a:lstStyle/>
-          <a:p/>
-        </p:txBody>
-      </p:sp>
+              <a:t>Sorted Full Gantt</a:t>
+            </a:r>
+          </a:p>
+        </p:txBody>
+      </p:sp>
+      <p:pic>
+        <p:nvPicPr>
+          <p:cNvPr id="3" name="Picture 2" descr="image.png"/>
+          <p:cNvPicPr>
+            <a:picLocks noChangeAspect="1"/>
+          </p:cNvPicPr>
+          <p:nvPr/>
+        </p:nvPicPr>
+        <p:blipFill>
+          <a:blip r:embed="rId2"/>
+          <a:stretch>
+            <a:fillRect/>
+          </a:stretch>
+        </p:blipFill>
+        <p:spPr>
+          <a:xfrm>
+            <a:off x="0" y="566928"/>
+            <a:ext cx="4800600" cy="4833277"/>
+          </a:xfrm>
+          <a:prstGeom prst="rect">
+            <a:avLst/>
+          </a:prstGeom>
+        </p:spPr>
+      </p:pic>
     </p:spTree>
   </p:cSld>
   <p:clrMapOvr>
@@ -3242,12 +3370,12 @@
       <p:grpSpPr/>
       <p:sp>
         <p:nvSpPr>
-          <p:cNvPr id="2" name="Title 1"/>
+          <p:cNvPr id="2" name="Text Placeholder 1"/>
           <p:cNvSpPr>
             <a:spLocks noGrp="1"/>
           </p:cNvSpPr>
           <p:nvPr>
-            <p:ph type="title"/>
+            <p:ph type="body" idx="10" sz="quarter"/>
           </p:nvPr>
         </p:nvSpPr>
         <p:spPr/>
@@ -3256,35 +3384,28 @@
           <a:lstStyle/>
           <a:p>
             <a:r>
-              <a:t>Full Gantt</a:t>
-            </a:r>
-          </a:p>
-        </p:txBody>
-      </p:sp>
-      <p:pic>
-        <p:nvPicPr>
-          <p:cNvPr id="3" name="Picture 2" descr="image.png"/>
-          <p:cNvPicPr>
-            <a:picLocks noChangeAspect="1"/>
-          </p:cNvPicPr>
-          <p:nvPr/>
-        </p:nvPicPr>
-        <p:blipFill>
-          <a:blip r:embed="rId2"/>
-          <a:stretch>
-            <a:fillRect/>
-          </a:stretch>
-        </p:blipFill>
-        <p:spPr>
-          <a:xfrm>
-            <a:off x="0" y="566928"/>
-            <a:ext cx="3886200" cy="3924797"/>
-          </a:xfrm>
-          <a:prstGeom prst="rect">
-            <a:avLst/>
-          </a:prstGeom>
-        </p:spPr>
-      </p:pic>
+              <a:t>example_atlantic_3</a:t>
+            </a:r>
+          </a:p>
+        </p:txBody>
+      </p:sp>
+      <p:sp>
+        <p:nvSpPr>
+          <p:cNvPr id="3" name="Text Placeholder 2"/>
+          <p:cNvSpPr>
+            <a:spLocks noGrp="1"/>
+          </p:cNvSpPr>
+          <p:nvPr>
+            <p:ph type="body" idx="11" sz="quarter"/>
+          </p:nvPr>
+        </p:nvSpPr>
+        <p:spPr/>
+        <p:txBody>
+          <a:bodyPr/>
+          <a:lstStyle/>
+          <a:p/>
+        </p:txBody>
+      </p:sp>
     </p:spTree>
   </p:cSld>
   <p:clrMapOvr>
@@ -3319,7 +3440,7 @@
           <a:lstStyle/>
           <a:p>
             <a:r>
-              <a:t>New England Gantt</a:t>
+              <a:t>Shared Resource Capacity - Vessels</a:t>
             </a:r>
           </a:p>
         </p:txBody>
@@ -3341,7 +3462,7 @@
         <p:spPr>
           <a:xfrm>
             <a:off x="0" y="566928"/>
-            <a:ext cx="12188952" cy="4186105"/>
+            <a:ext cx="3886200" cy="7906543"/>
           </a:xfrm>
           <a:prstGeom prst="rect">
             <a:avLst/>
@@ -3382,7 +3503,7 @@
           <a:lstStyle/>
           <a:p>
             <a:r>
-              <a:t>Fixed Gantt</a:t>
+              <a:t>Shared Resource Capacity - Ports</a:t>
             </a:r>
           </a:p>
         </p:txBody>
@@ -3404,7 +3525,7 @@
         <p:spPr>
           <a:xfrm>
             <a:off x="0" y="566928"/>
-            <a:ext cx="12188952" cy="10849756"/>
+            <a:ext cx="3886200" cy="7906543"/>
           </a:xfrm>
           <a:prstGeom prst="rect">
             <a:avLst/>
@@ -3431,12 +3552,12 @@
       <p:grpSpPr/>
       <p:sp>
         <p:nvSpPr>
-          <p:cNvPr id="2" name="Text Placeholder 1"/>
+          <p:cNvPr id="2" name="Title 1"/>
           <p:cNvSpPr>
             <a:spLocks noGrp="1"/>
           </p:cNvSpPr>
           <p:nvPr>
-            <p:ph type="body" idx="10" sz="quarter"/>
+            <p:ph type="title"/>
           </p:nvPr>
         </p:nvSpPr>
         <p:spPr/>
@@ -3445,28 +3566,35 @@
           <a:lstStyle/>
           <a:p>
             <a:r>
-              <a:t>example_atlantic_3</a:t>
-            </a:r>
-          </a:p>
-        </p:txBody>
-      </p:sp>
-      <p:sp>
-        <p:nvSpPr>
-          <p:cNvPr id="3" name="Text Placeholder 2"/>
-          <p:cNvSpPr>
-            <a:spLocks noGrp="1"/>
-          </p:cNvSpPr>
-          <p:nvPr>
-            <p:ph type="body" idx="11" sz="quarter"/>
-          </p:nvPr>
-        </p:nvSpPr>
-        <p:spPr/>
-        <p:txBody>
-          <a:bodyPr/>
-          <a:lstStyle/>
-          <a:p/>
-        </p:txBody>
-      </p:sp>
+              <a:t>Full Gantt</a:t>
+            </a:r>
+          </a:p>
+        </p:txBody>
+      </p:sp>
+      <p:pic>
+        <p:nvPicPr>
+          <p:cNvPr id="3" name="Picture 2" descr="image.png"/>
+          <p:cNvPicPr>
+            <a:picLocks noChangeAspect="1"/>
+          </p:cNvPicPr>
+          <p:nvPr/>
+        </p:nvPicPr>
+        <p:blipFill>
+          <a:blip r:embed="rId2"/>
+          <a:stretch>
+            <a:fillRect/>
+          </a:stretch>
+        </p:blipFill>
+        <p:spPr>
+          <a:xfrm>
+            <a:off x="0" y="566928"/>
+            <a:ext cx="3886200" cy="3924797"/>
+          </a:xfrm>
+          <a:prstGeom prst="rect">
+            <a:avLst/>
+          </a:prstGeom>
+        </p:spPr>
+      </p:pic>
     </p:spTree>
   </p:cSld>
   <p:clrMapOvr>

</xml_diff>

<commit_message>
add summary plotting functions and format
</commit_message>
<xml_diff>
--- a/postprocessing/results/example_atlantic/example_atlantic_results.pptx
+++ b/postprocessing/results/example_atlantic/example_atlantic_results.pptx
@@ -22,6 +22,46 @@
     <p:sldId id="270" r:id="rId20"/>
     <p:sldId id="271" r:id="rId21"/>
     <p:sldId id="272" r:id="rId22"/>
+    <p:sldId id="273" r:id="rId23"/>
+    <p:sldId id="274" r:id="rId24"/>
+    <p:sldId id="275" r:id="rId25"/>
+    <p:sldId id="276" r:id="rId26"/>
+    <p:sldId id="277" r:id="rId27"/>
+    <p:sldId id="278" r:id="rId28"/>
+    <p:sldId id="279" r:id="rId29"/>
+    <p:sldId id="280" r:id="rId30"/>
+    <p:sldId id="281" r:id="rId31"/>
+    <p:sldId id="282" r:id="rId32"/>
+    <p:sldId id="283" r:id="rId33"/>
+    <p:sldId id="284" r:id="rId34"/>
+    <p:sldId id="285" r:id="rId35"/>
+    <p:sldId id="286" r:id="rId36"/>
+    <p:sldId id="287" r:id="rId37"/>
+    <p:sldId id="288" r:id="rId38"/>
+    <p:sldId id="289" r:id="rId39"/>
+    <p:sldId id="290" r:id="rId40"/>
+    <p:sldId id="291" r:id="rId41"/>
+    <p:sldId id="292" r:id="rId42"/>
+    <p:sldId id="293" r:id="rId43"/>
+    <p:sldId id="294" r:id="rId44"/>
+    <p:sldId id="295" r:id="rId45"/>
+    <p:sldId id="296" r:id="rId46"/>
+    <p:sldId id="297" r:id="rId47"/>
+    <p:sldId id="298" r:id="rId48"/>
+    <p:sldId id="299" r:id="rId49"/>
+    <p:sldId id="300" r:id="rId50"/>
+    <p:sldId id="301" r:id="rId51"/>
+    <p:sldId id="302" r:id="rId52"/>
+    <p:sldId id="303" r:id="rId53"/>
+    <p:sldId id="304" r:id="rId54"/>
+    <p:sldId id="305" r:id="rId55"/>
+    <p:sldId id="306" r:id="rId56"/>
+    <p:sldId id="307" r:id="rId57"/>
+    <p:sldId id="308" r:id="rId58"/>
+    <p:sldId id="309" r:id="rId59"/>
+    <p:sldId id="310" r:id="rId60"/>
+    <p:sldId id="311" r:id="rId61"/>
+    <p:sldId id="312" r:id="rId62"/>
   </p:sldIdLst>
   <p:sldSz cx="12192000" cy="6858000"/>
   <p:notesSz cx="6858000" cy="9144000"/>
@@ -2586,7 +2626,7 @@
           <a:lstStyle/>
           <a:p>
             <a:r>
-              <a:t>example_atlantic_2</a:t>
+              <a:t>example_atlantic_3</a:t>
             </a:r>
           </a:p>
         </p:txBody>
@@ -2642,7 +2682,7 @@
           <a:lstStyle/>
           <a:p>
             <a:r>
-              <a:t>Sorted Full Gantt</a:t>
+              <a:t>Floating Gantt</a:t>
             </a:r>
           </a:p>
         </p:txBody>
@@ -2664,7 +2704,7 @@
         <p:spPr>
           <a:xfrm>
             <a:off x="0" y="566928"/>
-            <a:ext cx="4800600" cy="4848278"/>
+            <a:ext cx="12188952" cy="1658026"/>
           </a:xfrm>
           <a:prstGeom prst="rect">
             <a:avLst/>
@@ -2691,12 +2731,12 @@
       <p:grpSpPr/>
       <p:sp>
         <p:nvSpPr>
-          <p:cNvPr id="2" name="Text Placeholder 1"/>
-          <p:cNvSpPr>
-            <a:spLocks noGrp="1"/>
-          </p:cNvSpPr>
-          <p:nvPr>
-            <p:ph type="body" idx="10" sz="quarter"/>
+          <p:cNvPr id="2" name="Title 1"/>
+          <p:cNvSpPr>
+            <a:spLocks noGrp="1"/>
+          </p:cNvSpPr>
+          <p:nvPr>
+            <p:ph type="title"/>
           </p:nvPr>
         </p:nvSpPr>
         <p:spPr/>
@@ -2705,63 +2745,7 @@
           <a:lstStyle/>
           <a:p>
             <a:r>
-              <a:t>example_atlantic_1</a:t>
-            </a:r>
-          </a:p>
-        </p:txBody>
-      </p:sp>
-      <p:sp>
-        <p:nvSpPr>
-          <p:cNvPr id="3" name="Text Placeholder 2"/>
-          <p:cNvSpPr>
-            <a:spLocks noGrp="1"/>
-          </p:cNvSpPr>
-          <p:nvPr>
-            <p:ph type="body" idx="11" sz="quarter"/>
-          </p:nvPr>
-        </p:nvSpPr>
-        <p:spPr/>
-        <p:txBody>
-          <a:bodyPr/>
-          <a:lstStyle/>
-          <a:p/>
-        </p:txBody>
-      </p:sp>
-    </p:spTree>
-  </p:cSld>
-  <p:clrMapOvr>
-    <a:masterClrMapping/>
-  </p:clrMapOvr>
-</p:sld>
-</file>
-
-<file path=ppt/slides/slide12.xml><?xml version="1.0" encoding="utf-8"?>
-<p:sld xmlns:a="http://schemas.openxmlformats.org/drawingml/2006/main" xmlns:p="http://schemas.openxmlformats.org/presentationml/2006/main" xmlns:r="http://schemas.openxmlformats.org/officeDocument/2006/relationships">
-  <p:cSld>
-    <p:spTree>
-      <p:nvGrpSpPr>
-        <p:cNvPr id="1" name=""/>
-        <p:cNvGrpSpPr/>
-        <p:nvPr/>
-      </p:nvGrpSpPr>
-      <p:grpSpPr/>
-      <p:sp>
-        <p:nvSpPr>
-          <p:cNvPr id="2" name="Title 1"/>
-          <p:cNvSpPr>
-            <a:spLocks noGrp="1"/>
-          </p:cNvSpPr>
-          <p:nvPr>
-            <p:ph type="title"/>
-          </p:nvPr>
-        </p:nvSpPr>
-        <p:spPr/>
-        <p:txBody>
-          <a:bodyPr/>
-          <a:lstStyle/>
-          <a:p>
-            <a:r>
-              <a:t>Shared Resource Capacity - Vessels</a:t>
+              <a:t>Sorted Floating Gantt</a:t>
             </a:r>
           </a:p>
         </p:txBody>
@@ -2783,7 +2767,7 @@
         <p:spPr>
           <a:xfrm>
             <a:off x="0" y="566928"/>
-            <a:ext cx="3886200" cy="7906543"/>
+            <a:ext cx="12188952" cy="1658026"/>
           </a:xfrm>
           <a:prstGeom prst="rect">
             <a:avLst/>
@@ -2798,7 +2782,7 @@
 </p:sld>
 </file>
 
-<file path=ppt/slides/slide13.xml><?xml version="1.0" encoding="utf-8"?>
+<file path=ppt/slides/slide12.xml><?xml version="1.0" encoding="utf-8"?>
 <p:sld xmlns:a="http://schemas.openxmlformats.org/drawingml/2006/main" xmlns:p="http://schemas.openxmlformats.org/presentationml/2006/main" xmlns:r="http://schemas.openxmlformats.org/officeDocument/2006/relationships">
   <p:cSld>
     <p:spTree>
@@ -2824,7 +2808,7 @@
           <a:lstStyle/>
           <a:p>
             <a:r>
-              <a:t>Shared Resource Capacity - Ports</a:t>
+              <a:t>Vessel Utilization</a:t>
             </a:r>
           </a:p>
         </p:txBody>
@@ -2846,7 +2830,7 @@
         <p:spPr>
           <a:xfrm>
             <a:off x="0" y="566928"/>
-            <a:ext cx="3886200" cy="7906543"/>
+            <a:ext cx="12188952" cy="8650224"/>
           </a:xfrm>
           <a:prstGeom prst="rect">
             <a:avLst/>
@@ -2861,7 +2845,7 @@
 </p:sld>
 </file>
 
-<file path=ppt/slides/slide14.xml><?xml version="1.0" encoding="utf-8"?>
+<file path=ppt/slides/slide13.xml><?xml version="1.0" encoding="utf-8"?>
 <p:sld xmlns:a="http://schemas.openxmlformats.org/drawingml/2006/main" xmlns:p="http://schemas.openxmlformats.org/presentationml/2006/main" xmlns:r="http://schemas.openxmlformats.org/officeDocument/2006/relationships">
   <p:cSld>
     <p:spTree>
@@ -2887,7 +2871,7 @@
           <a:lstStyle/>
           <a:p>
             <a:r>
-              <a:t>Full Gantt</a:t>
+              <a:t>Port Throughput</a:t>
             </a:r>
           </a:p>
         </p:txBody>
@@ -2909,7 +2893,7 @@
         <p:spPr>
           <a:xfrm>
             <a:off x="0" y="566928"/>
-            <a:ext cx="3886200" cy="3917501"/>
+            <a:ext cx="12188952" cy="8228396"/>
           </a:xfrm>
           <a:prstGeom prst="rect">
             <a:avLst/>
@@ -2924,7 +2908,7 @@
 </p:sld>
 </file>
 
-<file path=ppt/slides/slide15.xml><?xml version="1.0" encoding="utf-8"?>
+<file path=ppt/slides/slide14.xml><?xml version="1.0" encoding="utf-8"?>
 <p:sld xmlns:a="http://schemas.openxmlformats.org/drawingml/2006/main" xmlns:p="http://schemas.openxmlformats.org/presentationml/2006/main" xmlns:r="http://schemas.openxmlformats.org/officeDocument/2006/relationships">
   <p:cSld>
     <p:spTree>
@@ -2950,7 +2934,7 @@
           <a:lstStyle/>
           <a:p>
             <a:r>
-              <a:t>Sorted Full Gantt</a:t>
+              <a:t>Port Throughput</a:t>
             </a:r>
           </a:p>
         </p:txBody>
@@ -2972,7 +2956,7 @@
         <p:spPr>
           <a:xfrm>
             <a:off x="0" y="566928"/>
-            <a:ext cx="4800600" cy="4839267"/>
+            <a:ext cx="12188952" cy="8228396"/>
           </a:xfrm>
           <a:prstGeom prst="rect">
             <a:avLst/>
@@ -2987,7 +2971,7 @@
 </p:sld>
 </file>
 
-<file path=ppt/slides/slide16.xml><?xml version="1.0" encoding="utf-8"?>
+<file path=ppt/slides/slide15.xml><?xml version="1.0" encoding="utf-8"?>
 <p:sld xmlns:a="http://schemas.openxmlformats.org/drawingml/2006/main" xmlns:p="http://schemas.openxmlformats.org/presentationml/2006/main" xmlns:r="http://schemas.openxmlformats.org/officeDocument/2006/relationships">
   <p:cSld>
     <p:spTree>
@@ -3013,7 +2997,7 @@
           <a:lstStyle/>
           <a:p>
             <a:r>
-              <a:t>Summary Plots</a:t>
+              <a:t>example_atlantic_2</a:t>
             </a:r>
           </a:p>
         </p:txBody>
@@ -3043,7 +3027,7 @@
 </p:sld>
 </file>
 
-<file path=ppt/slides/slide17.xml><?xml version="1.0" encoding="utf-8"?>
+<file path=ppt/slides/slide16.xml><?xml version="1.0" encoding="utf-8"?>
 <p:sld xmlns:a="http://schemas.openxmlformats.org/drawingml/2006/main" xmlns:p="http://schemas.openxmlformats.org/presentationml/2006/main" xmlns:r="http://schemas.openxmlformats.org/officeDocument/2006/relationships">
   <p:cSld>
     <p:spTree>
@@ -3069,7 +3053,7 @@
           <a:lstStyle/>
           <a:p>
             <a:r>
-              <a:t>Cumulative Installed Capacity</a:t>
+              <a:t>Shared Resource Capacity - Vessels</a:t>
             </a:r>
           </a:p>
         </p:txBody>
@@ -3091,7 +3075,7 @@
         <p:spPr>
           <a:xfrm>
             <a:off x="0" y="566928"/>
-            <a:ext cx="12188952" cy="5091404"/>
+            <a:ext cx="3886200" cy="7906543"/>
           </a:xfrm>
           <a:prstGeom prst="rect">
             <a:avLst/>
@@ -3106,7 +3090,7 @@
 </p:sld>
 </file>
 
-<file path=ppt/slides/slide2.xml><?xml version="1.0" encoding="utf-8"?>
+<file path=ppt/slides/slide17.xml><?xml version="1.0" encoding="utf-8"?>
 <p:sld xmlns:a="http://schemas.openxmlformats.org/drawingml/2006/main" xmlns:p="http://schemas.openxmlformats.org/presentationml/2006/main" xmlns:r="http://schemas.openxmlformats.org/officeDocument/2006/relationships">
   <p:cSld>
     <p:spTree>
@@ -3132,7 +3116,7 @@
           <a:lstStyle/>
           <a:p>
             <a:r>
-              <a:t>Shared Resource Capacity - Vessels</a:t>
+              <a:t>Shared Resource Capacity - Ports</a:t>
             </a:r>
           </a:p>
         </p:txBody>
@@ -3169,7 +3153,7 @@
 </p:sld>
 </file>
 
-<file path=ppt/slides/slide3.xml><?xml version="1.0" encoding="utf-8"?>
+<file path=ppt/slides/slide18.xml><?xml version="1.0" encoding="utf-8"?>
 <p:sld xmlns:a="http://schemas.openxmlformats.org/drawingml/2006/main" xmlns:p="http://schemas.openxmlformats.org/presentationml/2006/main" xmlns:r="http://schemas.openxmlformats.org/officeDocument/2006/relationships">
   <p:cSld>
     <p:spTree>
@@ -3195,7 +3179,7 @@
           <a:lstStyle/>
           <a:p>
             <a:r>
-              <a:t>Shared Resource Capacity - Ports</a:t>
+              <a:t>Full Gantt</a:t>
             </a:r>
           </a:p>
         </p:txBody>
@@ -3217,7 +3201,7 @@
         <p:spPr>
           <a:xfrm>
             <a:off x="0" y="566928"/>
-            <a:ext cx="3886200" cy="7906543"/>
+            <a:ext cx="3886200" cy="3912653"/>
           </a:xfrm>
           <a:prstGeom prst="rect">
             <a:avLst/>
@@ -3232,7 +3216,7 @@
 </p:sld>
 </file>
 
-<file path=ppt/slides/slide4.xml><?xml version="1.0" encoding="utf-8"?>
+<file path=ppt/slides/slide19.xml><?xml version="1.0" encoding="utf-8"?>
 <p:sld xmlns:a="http://schemas.openxmlformats.org/drawingml/2006/main" xmlns:p="http://schemas.openxmlformats.org/presentationml/2006/main" xmlns:r="http://schemas.openxmlformats.org/officeDocument/2006/relationships">
   <p:cSld>
     <p:spTree>
@@ -3258,7 +3242,7 @@
           <a:lstStyle/>
           <a:p>
             <a:r>
-              <a:t>Full Gantt</a:t>
+              <a:t>Sorted Full Gantt</a:t>
             </a:r>
           </a:p>
         </p:txBody>
@@ -3280,7 +3264,7 @@
         <p:spPr>
           <a:xfrm>
             <a:off x="0" y="566928"/>
-            <a:ext cx="3886200" cy="3912653"/>
+            <a:ext cx="4800600" cy="4833277"/>
           </a:xfrm>
           <a:prstGeom prst="rect">
             <a:avLst/>
@@ -3295,7 +3279,7 @@
 </p:sld>
 </file>
 
-<file path=ppt/slides/slide5.xml><?xml version="1.0" encoding="utf-8"?>
+<file path=ppt/slides/slide2.xml><?xml version="1.0" encoding="utf-8"?>
 <p:sld xmlns:a="http://schemas.openxmlformats.org/drawingml/2006/main" xmlns:p="http://schemas.openxmlformats.org/presentationml/2006/main" xmlns:r="http://schemas.openxmlformats.org/officeDocument/2006/relationships">
   <p:cSld>
     <p:spTree>
@@ -3321,7 +3305,7 @@
           <a:lstStyle/>
           <a:p>
             <a:r>
-              <a:t>Sorted Full Gantt</a:t>
+              <a:t>Shared Resource Capacity - Vessels</a:t>
             </a:r>
           </a:p>
         </p:txBody>
@@ -3343,7 +3327,7 @@
         <p:spPr>
           <a:xfrm>
             <a:off x="0" y="566928"/>
-            <a:ext cx="4800600" cy="4833277"/>
+            <a:ext cx="3886200" cy="7906543"/>
           </a:xfrm>
           <a:prstGeom prst="rect">
             <a:avLst/>
@@ -3358,7 +3342,7 @@
 </p:sld>
 </file>
 
-<file path=ppt/slides/slide6.xml><?xml version="1.0" encoding="utf-8"?>
+<file path=ppt/slides/slide20.xml><?xml version="1.0" encoding="utf-8"?>
 <p:sld xmlns:a="http://schemas.openxmlformats.org/drawingml/2006/main" xmlns:p="http://schemas.openxmlformats.org/presentationml/2006/main" xmlns:r="http://schemas.openxmlformats.org/officeDocument/2006/relationships">
   <p:cSld>
     <p:spTree>
@@ -3370,12 +3354,12 @@
       <p:grpSpPr/>
       <p:sp>
         <p:nvSpPr>
-          <p:cNvPr id="2" name="Text Placeholder 1"/>
-          <p:cNvSpPr>
-            <a:spLocks noGrp="1"/>
-          </p:cNvSpPr>
-          <p:nvPr>
-            <p:ph type="body" idx="10" sz="quarter"/>
+          <p:cNvPr id="2" name="Title 1"/>
+          <p:cNvSpPr>
+            <a:spLocks noGrp="1"/>
+          </p:cNvSpPr>
+          <p:nvPr>
+            <p:ph type="title"/>
           </p:nvPr>
         </p:nvSpPr>
         <p:spPr/>
@@ -3384,63 +3368,7 @@
           <a:lstStyle/>
           <a:p>
             <a:r>
-              <a:t>example_atlantic_3</a:t>
-            </a:r>
-          </a:p>
-        </p:txBody>
-      </p:sp>
-      <p:sp>
-        <p:nvSpPr>
-          <p:cNvPr id="3" name="Text Placeholder 2"/>
-          <p:cNvSpPr>
-            <a:spLocks noGrp="1"/>
-          </p:cNvSpPr>
-          <p:nvPr>
-            <p:ph type="body" idx="11" sz="quarter"/>
-          </p:nvPr>
-        </p:nvSpPr>
-        <p:spPr/>
-        <p:txBody>
-          <a:bodyPr/>
-          <a:lstStyle/>
-          <a:p/>
-        </p:txBody>
-      </p:sp>
-    </p:spTree>
-  </p:cSld>
-  <p:clrMapOvr>
-    <a:masterClrMapping/>
-  </p:clrMapOvr>
-</p:sld>
-</file>
-
-<file path=ppt/slides/slide7.xml><?xml version="1.0" encoding="utf-8"?>
-<p:sld xmlns:a="http://schemas.openxmlformats.org/drawingml/2006/main" xmlns:p="http://schemas.openxmlformats.org/presentationml/2006/main" xmlns:r="http://schemas.openxmlformats.org/officeDocument/2006/relationships">
-  <p:cSld>
-    <p:spTree>
-      <p:nvGrpSpPr>
-        <p:cNvPr id="1" name=""/>
-        <p:cNvGrpSpPr/>
-        <p:nvPr/>
-      </p:nvGrpSpPr>
-      <p:grpSpPr/>
-      <p:sp>
-        <p:nvSpPr>
-          <p:cNvPr id="2" name="Title 1"/>
-          <p:cNvSpPr>
-            <a:spLocks noGrp="1"/>
-          </p:cNvSpPr>
-          <p:nvPr>
-            <p:ph type="title"/>
-          </p:nvPr>
-        </p:nvSpPr>
-        <p:spPr/>
-        <p:txBody>
-          <a:bodyPr/>
-          <a:lstStyle/>
-          <a:p>
-            <a:r>
-              <a:t>Shared Resource Capacity - Vessels</a:t>
+              <a:t>New England Gantt</a:t>
             </a:r>
           </a:p>
         </p:txBody>
@@ -3462,7 +3390,7 @@
         <p:spPr>
           <a:xfrm>
             <a:off x="0" y="566928"/>
-            <a:ext cx="3886200" cy="7906543"/>
+            <a:ext cx="12188952" cy="4186105"/>
           </a:xfrm>
           <a:prstGeom prst="rect">
             <a:avLst/>
@@ -3477,7 +3405,7 @@
 </p:sld>
 </file>
 
-<file path=ppt/slides/slide8.xml><?xml version="1.0" encoding="utf-8"?>
+<file path=ppt/slides/slide21.xml><?xml version="1.0" encoding="utf-8"?>
 <p:sld xmlns:a="http://schemas.openxmlformats.org/drawingml/2006/main" xmlns:p="http://schemas.openxmlformats.org/presentationml/2006/main" xmlns:r="http://schemas.openxmlformats.org/officeDocument/2006/relationships">
   <p:cSld>
     <p:spTree>
@@ -3503,7 +3431,7 @@
           <a:lstStyle/>
           <a:p>
             <a:r>
-              <a:t>Shared Resource Capacity - Ports</a:t>
+              <a:t>Sorted New England Gantt</a:t>
             </a:r>
           </a:p>
         </p:txBody>
@@ -3525,7 +3453,7 @@
         <p:spPr>
           <a:xfrm>
             <a:off x="0" y="566928"/>
-            <a:ext cx="3886200" cy="7906543"/>
+            <a:ext cx="12188952" cy="4186105"/>
           </a:xfrm>
           <a:prstGeom prst="rect">
             <a:avLst/>
@@ -3540,7 +3468,7 @@
 </p:sld>
 </file>
 
-<file path=ppt/slides/slide9.xml><?xml version="1.0" encoding="utf-8"?>
+<file path=ppt/slides/slide22.xml><?xml version="1.0" encoding="utf-8"?>
 <p:sld xmlns:a="http://schemas.openxmlformats.org/drawingml/2006/main" xmlns:p="http://schemas.openxmlformats.org/presentationml/2006/main" xmlns:r="http://schemas.openxmlformats.org/officeDocument/2006/relationships">
   <p:cSld>
     <p:spTree>
@@ -3566,7 +3494,7 @@
           <a:lstStyle/>
           <a:p>
             <a:r>
-              <a:t>Full Gantt</a:t>
+              <a:t>Fixed Gantt</a:t>
             </a:r>
           </a:p>
         </p:txBody>
@@ -3588,7 +3516,2639 @@
         <p:spPr>
           <a:xfrm>
             <a:off x="0" y="566928"/>
+            <a:ext cx="12188952" cy="10816186"/>
+          </a:xfrm>
+          <a:prstGeom prst="rect">
+            <a:avLst/>
+          </a:prstGeom>
+        </p:spPr>
+      </p:pic>
+    </p:spTree>
+  </p:cSld>
+  <p:clrMapOvr>
+    <a:masterClrMapping/>
+  </p:clrMapOvr>
+</p:sld>
+</file>
+
+<file path=ppt/slides/slide23.xml><?xml version="1.0" encoding="utf-8"?>
+<p:sld xmlns:a="http://schemas.openxmlformats.org/drawingml/2006/main" xmlns:p="http://schemas.openxmlformats.org/presentationml/2006/main" xmlns:r="http://schemas.openxmlformats.org/officeDocument/2006/relationships">
+  <p:cSld>
+    <p:spTree>
+      <p:nvGrpSpPr>
+        <p:cNvPr id="1" name=""/>
+        <p:cNvGrpSpPr/>
+        <p:nvPr/>
+      </p:nvGrpSpPr>
+      <p:grpSpPr/>
+      <p:sp>
+        <p:nvSpPr>
+          <p:cNvPr id="2" name="Title 1"/>
+          <p:cNvSpPr>
+            <a:spLocks noGrp="1"/>
+          </p:cNvSpPr>
+          <p:nvPr>
+            <p:ph type="title"/>
+          </p:nvPr>
+        </p:nvSpPr>
+        <p:spPr/>
+        <p:txBody>
+          <a:bodyPr/>
+          <a:lstStyle/>
+          <a:p>
+            <a:r>
+              <a:t>Sorted Fixed Gantt</a:t>
+            </a:r>
+          </a:p>
+        </p:txBody>
+      </p:sp>
+      <p:pic>
+        <p:nvPicPr>
+          <p:cNvPr id="3" name="Picture 2" descr="image.png"/>
+          <p:cNvPicPr>
+            <a:picLocks noChangeAspect="1"/>
+          </p:cNvPicPr>
+          <p:nvPr/>
+        </p:nvPicPr>
+        <p:blipFill>
+          <a:blip r:embed="rId2"/>
+          <a:stretch>
+            <a:fillRect/>
+          </a:stretch>
+        </p:blipFill>
+        <p:spPr>
+          <a:xfrm>
+            <a:off x="0" y="566928"/>
+            <a:ext cx="12188952" cy="10816186"/>
+          </a:xfrm>
+          <a:prstGeom prst="rect">
+            <a:avLst/>
+          </a:prstGeom>
+        </p:spPr>
+      </p:pic>
+    </p:spTree>
+  </p:cSld>
+  <p:clrMapOvr>
+    <a:masterClrMapping/>
+  </p:clrMapOvr>
+</p:sld>
+</file>
+
+<file path=ppt/slides/slide24.xml><?xml version="1.0" encoding="utf-8"?>
+<p:sld xmlns:a="http://schemas.openxmlformats.org/drawingml/2006/main" xmlns:p="http://schemas.openxmlformats.org/presentationml/2006/main" xmlns:r="http://schemas.openxmlformats.org/officeDocument/2006/relationships">
+  <p:cSld>
+    <p:spTree>
+      <p:nvGrpSpPr>
+        <p:cNvPr id="1" name=""/>
+        <p:cNvGrpSpPr/>
+        <p:nvPr/>
+      </p:nvGrpSpPr>
+      <p:grpSpPr/>
+      <p:sp>
+        <p:nvSpPr>
+          <p:cNvPr id="2" name="Title 1"/>
+          <p:cNvSpPr>
+            <a:spLocks noGrp="1"/>
+          </p:cNvSpPr>
+          <p:nvPr>
+            <p:ph type="title"/>
+          </p:nvPr>
+        </p:nvSpPr>
+        <p:spPr/>
+        <p:txBody>
+          <a:bodyPr/>
+          <a:lstStyle/>
+          <a:p>
+            <a:r>
+              <a:t>Floating Gantt</a:t>
+            </a:r>
+          </a:p>
+        </p:txBody>
+      </p:sp>
+      <p:pic>
+        <p:nvPicPr>
+          <p:cNvPr id="3" name="Picture 2" descr="image.png"/>
+          <p:cNvPicPr>
+            <a:picLocks noChangeAspect="1"/>
+          </p:cNvPicPr>
+          <p:nvPr/>
+        </p:nvPicPr>
+        <p:blipFill>
+          <a:blip r:embed="rId2"/>
+          <a:stretch>
+            <a:fillRect/>
+          </a:stretch>
+        </p:blipFill>
+        <p:spPr>
+          <a:xfrm>
+            <a:off x="0" y="566928"/>
+            <a:ext cx="12188952" cy="1658026"/>
+          </a:xfrm>
+          <a:prstGeom prst="rect">
+            <a:avLst/>
+          </a:prstGeom>
+        </p:spPr>
+      </p:pic>
+    </p:spTree>
+  </p:cSld>
+  <p:clrMapOvr>
+    <a:masterClrMapping/>
+  </p:clrMapOvr>
+</p:sld>
+</file>
+
+<file path=ppt/slides/slide25.xml><?xml version="1.0" encoding="utf-8"?>
+<p:sld xmlns:a="http://schemas.openxmlformats.org/drawingml/2006/main" xmlns:p="http://schemas.openxmlformats.org/presentationml/2006/main" xmlns:r="http://schemas.openxmlformats.org/officeDocument/2006/relationships">
+  <p:cSld>
+    <p:spTree>
+      <p:nvGrpSpPr>
+        <p:cNvPr id="1" name=""/>
+        <p:cNvGrpSpPr/>
+        <p:nvPr/>
+      </p:nvGrpSpPr>
+      <p:grpSpPr/>
+      <p:sp>
+        <p:nvSpPr>
+          <p:cNvPr id="2" name="Title 1"/>
+          <p:cNvSpPr>
+            <a:spLocks noGrp="1"/>
+          </p:cNvSpPr>
+          <p:nvPr>
+            <p:ph type="title"/>
+          </p:nvPr>
+        </p:nvSpPr>
+        <p:spPr/>
+        <p:txBody>
+          <a:bodyPr/>
+          <a:lstStyle/>
+          <a:p>
+            <a:r>
+              <a:t>Sorted Floating Gantt</a:t>
+            </a:r>
+          </a:p>
+        </p:txBody>
+      </p:sp>
+      <p:pic>
+        <p:nvPicPr>
+          <p:cNvPr id="3" name="Picture 2" descr="image.png"/>
+          <p:cNvPicPr>
+            <a:picLocks noChangeAspect="1"/>
+          </p:cNvPicPr>
+          <p:nvPr/>
+        </p:nvPicPr>
+        <p:blipFill>
+          <a:blip r:embed="rId2"/>
+          <a:stretch>
+            <a:fillRect/>
+          </a:stretch>
+        </p:blipFill>
+        <p:spPr>
+          <a:xfrm>
+            <a:off x="0" y="566928"/>
+            <a:ext cx="12188952" cy="1658026"/>
+          </a:xfrm>
+          <a:prstGeom prst="rect">
+            <a:avLst/>
+          </a:prstGeom>
+        </p:spPr>
+      </p:pic>
+    </p:spTree>
+  </p:cSld>
+  <p:clrMapOvr>
+    <a:masterClrMapping/>
+  </p:clrMapOvr>
+</p:sld>
+</file>
+
+<file path=ppt/slides/slide26.xml><?xml version="1.0" encoding="utf-8"?>
+<p:sld xmlns:a="http://schemas.openxmlformats.org/drawingml/2006/main" xmlns:p="http://schemas.openxmlformats.org/presentationml/2006/main" xmlns:r="http://schemas.openxmlformats.org/officeDocument/2006/relationships">
+  <p:cSld>
+    <p:spTree>
+      <p:nvGrpSpPr>
+        <p:cNvPr id="1" name=""/>
+        <p:cNvGrpSpPr/>
+        <p:nvPr/>
+      </p:nvGrpSpPr>
+      <p:grpSpPr/>
+      <p:sp>
+        <p:nvSpPr>
+          <p:cNvPr id="2" name="Title 1"/>
+          <p:cNvSpPr>
+            <a:spLocks noGrp="1"/>
+          </p:cNvSpPr>
+          <p:nvPr>
+            <p:ph type="title"/>
+          </p:nvPr>
+        </p:nvSpPr>
+        <p:spPr/>
+        <p:txBody>
+          <a:bodyPr/>
+          <a:lstStyle/>
+          <a:p>
+            <a:r>
+              <a:t>Vessel Utilization</a:t>
+            </a:r>
+          </a:p>
+        </p:txBody>
+      </p:sp>
+      <p:pic>
+        <p:nvPicPr>
+          <p:cNvPr id="3" name="Picture 2" descr="image.png"/>
+          <p:cNvPicPr>
+            <a:picLocks noChangeAspect="1"/>
+          </p:cNvPicPr>
+          <p:nvPr/>
+        </p:nvPicPr>
+        <p:blipFill>
+          <a:blip r:embed="rId2"/>
+          <a:stretch>
+            <a:fillRect/>
+          </a:stretch>
+        </p:blipFill>
+        <p:spPr>
+          <a:xfrm>
+            <a:off x="0" y="566928"/>
+            <a:ext cx="12188952" cy="8650224"/>
+          </a:xfrm>
+          <a:prstGeom prst="rect">
+            <a:avLst/>
+          </a:prstGeom>
+        </p:spPr>
+      </p:pic>
+    </p:spTree>
+  </p:cSld>
+  <p:clrMapOvr>
+    <a:masterClrMapping/>
+  </p:clrMapOvr>
+</p:sld>
+</file>
+
+<file path=ppt/slides/slide27.xml><?xml version="1.0" encoding="utf-8"?>
+<p:sld xmlns:a="http://schemas.openxmlformats.org/drawingml/2006/main" xmlns:p="http://schemas.openxmlformats.org/presentationml/2006/main" xmlns:r="http://schemas.openxmlformats.org/officeDocument/2006/relationships">
+  <p:cSld>
+    <p:spTree>
+      <p:nvGrpSpPr>
+        <p:cNvPr id="1" name=""/>
+        <p:cNvGrpSpPr/>
+        <p:nvPr/>
+      </p:nvGrpSpPr>
+      <p:grpSpPr/>
+      <p:sp>
+        <p:nvSpPr>
+          <p:cNvPr id="2" name="Title 1"/>
+          <p:cNvSpPr>
+            <a:spLocks noGrp="1"/>
+          </p:cNvSpPr>
+          <p:nvPr>
+            <p:ph type="title"/>
+          </p:nvPr>
+        </p:nvSpPr>
+        <p:spPr/>
+        <p:txBody>
+          <a:bodyPr/>
+          <a:lstStyle/>
+          <a:p>
+            <a:r>
+              <a:t>Port Throughput</a:t>
+            </a:r>
+          </a:p>
+        </p:txBody>
+      </p:sp>
+      <p:pic>
+        <p:nvPicPr>
+          <p:cNvPr id="3" name="Picture 2" descr="image.png"/>
+          <p:cNvPicPr>
+            <a:picLocks noChangeAspect="1"/>
+          </p:cNvPicPr>
+          <p:nvPr/>
+        </p:nvPicPr>
+        <p:blipFill>
+          <a:blip r:embed="rId2"/>
+          <a:stretch>
+            <a:fillRect/>
+          </a:stretch>
+        </p:blipFill>
+        <p:spPr>
+          <a:xfrm>
+            <a:off x="0" y="566928"/>
+            <a:ext cx="12188952" cy="8228396"/>
+          </a:xfrm>
+          <a:prstGeom prst="rect">
+            <a:avLst/>
+          </a:prstGeom>
+        </p:spPr>
+      </p:pic>
+    </p:spTree>
+  </p:cSld>
+  <p:clrMapOvr>
+    <a:masterClrMapping/>
+  </p:clrMapOvr>
+</p:sld>
+</file>
+
+<file path=ppt/slides/slide28.xml><?xml version="1.0" encoding="utf-8"?>
+<p:sld xmlns:a="http://schemas.openxmlformats.org/drawingml/2006/main" xmlns:p="http://schemas.openxmlformats.org/presentationml/2006/main" xmlns:r="http://schemas.openxmlformats.org/officeDocument/2006/relationships">
+  <p:cSld>
+    <p:spTree>
+      <p:nvGrpSpPr>
+        <p:cNvPr id="1" name=""/>
+        <p:cNvGrpSpPr/>
+        <p:nvPr/>
+      </p:nvGrpSpPr>
+      <p:grpSpPr/>
+      <p:sp>
+        <p:nvSpPr>
+          <p:cNvPr id="2" name="Title 1"/>
+          <p:cNvSpPr>
+            <a:spLocks noGrp="1"/>
+          </p:cNvSpPr>
+          <p:nvPr>
+            <p:ph type="title"/>
+          </p:nvPr>
+        </p:nvSpPr>
+        <p:spPr/>
+        <p:txBody>
+          <a:bodyPr/>
+          <a:lstStyle/>
+          <a:p>
+            <a:r>
+              <a:t>Port Throughput</a:t>
+            </a:r>
+          </a:p>
+        </p:txBody>
+      </p:sp>
+      <p:pic>
+        <p:nvPicPr>
+          <p:cNvPr id="3" name="Picture 2" descr="image.png"/>
+          <p:cNvPicPr>
+            <a:picLocks noChangeAspect="1"/>
+          </p:cNvPicPr>
+          <p:nvPr/>
+        </p:nvPicPr>
+        <p:blipFill>
+          <a:blip r:embed="rId2"/>
+          <a:stretch>
+            <a:fillRect/>
+          </a:stretch>
+        </p:blipFill>
+        <p:spPr>
+          <a:xfrm>
+            <a:off x="0" y="566928"/>
+            <a:ext cx="12188952" cy="8228396"/>
+          </a:xfrm>
+          <a:prstGeom prst="rect">
+            <a:avLst/>
+          </a:prstGeom>
+        </p:spPr>
+      </p:pic>
+    </p:spTree>
+  </p:cSld>
+  <p:clrMapOvr>
+    <a:masterClrMapping/>
+  </p:clrMapOvr>
+</p:sld>
+</file>
+
+<file path=ppt/slides/slide29.xml><?xml version="1.0" encoding="utf-8"?>
+<p:sld xmlns:a="http://schemas.openxmlformats.org/drawingml/2006/main" xmlns:p="http://schemas.openxmlformats.org/presentationml/2006/main" xmlns:r="http://schemas.openxmlformats.org/officeDocument/2006/relationships">
+  <p:cSld>
+    <p:spTree>
+      <p:nvGrpSpPr>
+        <p:cNvPr id="1" name=""/>
+        <p:cNvGrpSpPr/>
+        <p:nvPr/>
+      </p:nvGrpSpPr>
+      <p:grpSpPr/>
+      <p:sp>
+        <p:nvSpPr>
+          <p:cNvPr id="2" name="Text Placeholder 1"/>
+          <p:cNvSpPr>
+            <a:spLocks noGrp="1"/>
+          </p:cNvSpPr>
+          <p:nvPr>
+            <p:ph type="body" idx="10" sz="quarter"/>
+          </p:nvPr>
+        </p:nvSpPr>
+        <p:spPr/>
+        <p:txBody>
+          <a:bodyPr/>
+          <a:lstStyle/>
+          <a:p>
+            <a:r>
+              <a:t>example_atlantic_1</a:t>
+            </a:r>
+          </a:p>
+        </p:txBody>
+      </p:sp>
+      <p:sp>
+        <p:nvSpPr>
+          <p:cNvPr id="3" name="Text Placeholder 2"/>
+          <p:cNvSpPr>
+            <a:spLocks noGrp="1"/>
+          </p:cNvSpPr>
+          <p:nvPr>
+            <p:ph type="body" idx="11" sz="quarter"/>
+          </p:nvPr>
+        </p:nvSpPr>
+        <p:spPr/>
+        <p:txBody>
+          <a:bodyPr/>
+          <a:lstStyle/>
+          <a:p/>
+        </p:txBody>
+      </p:sp>
+    </p:spTree>
+  </p:cSld>
+  <p:clrMapOvr>
+    <a:masterClrMapping/>
+  </p:clrMapOvr>
+</p:sld>
+</file>
+
+<file path=ppt/slides/slide3.xml><?xml version="1.0" encoding="utf-8"?>
+<p:sld xmlns:a="http://schemas.openxmlformats.org/drawingml/2006/main" xmlns:p="http://schemas.openxmlformats.org/presentationml/2006/main" xmlns:r="http://schemas.openxmlformats.org/officeDocument/2006/relationships">
+  <p:cSld>
+    <p:spTree>
+      <p:nvGrpSpPr>
+        <p:cNvPr id="1" name=""/>
+        <p:cNvGrpSpPr/>
+        <p:nvPr/>
+      </p:nvGrpSpPr>
+      <p:grpSpPr/>
+      <p:sp>
+        <p:nvSpPr>
+          <p:cNvPr id="2" name="Title 1"/>
+          <p:cNvSpPr>
+            <a:spLocks noGrp="1"/>
+          </p:cNvSpPr>
+          <p:nvPr>
+            <p:ph type="title"/>
+          </p:nvPr>
+        </p:nvSpPr>
+        <p:spPr/>
+        <p:txBody>
+          <a:bodyPr/>
+          <a:lstStyle/>
+          <a:p>
+            <a:r>
+              <a:t>Shared Resource Capacity - Ports</a:t>
+            </a:r>
+          </a:p>
+        </p:txBody>
+      </p:sp>
+      <p:pic>
+        <p:nvPicPr>
+          <p:cNvPr id="3" name="Picture 2" descr="image.png"/>
+          <p:cNvPicPr>
+            <a:picLocks noChangeAspect="1"/>
+          </p:cNvPicPr>
+          <p:nvPr/>
+        </p:nvPicPr>
+        <p:blipFill>
+          <a:blip r:embed="rId2"/>
+          <a:stretch>
+            <a:fillRect/>
+          </a:stretch>
+        </p:blipFill>
+        <p:spPr>
+          <a:xfrm>
+            <a:off x="0" y="566928"/>
+            <a:ext cx="3886200" cy="7906543"/>
+          </a:xfrm>
+          <a:prstGeom prst="rect">
+            <a:avLst/>
+          </a:prstGeom>
+        </p:spPr>
+      </p:pic>
+    </p:spTree>
+  </p:cSld>
+  <p:clrMapOvr>
+    <a:masterClrMapping/>
+  </p:clrMapOvr>
+</p:sld>
+</file>
+
+<file path=ppt/slides/slide30.xml><?xml version="1.0" encoding="utf-8"?>
+<p:sld xmlns:a="http://schemas.openxmlformats.org/drawingml/2006/main" xmlns:p="http://schemas.openxmlformats.org/presentationml/2006/main" xmlns:r="http://schemas.openxmlformats.org/officeDocument/2006/relationships">
+  <p:cSld>
+    <p:spTree>
+      <p:nvGrpSpPr>
+        <p:cNvPr id="1" name=""/>
+        <p:cNvGrpSpPr/>
+        <p:nvPr/>
+      </p:nvGrpSpPr>
+      <p:grpSpPr/>
+      <p:sp>
+        <p:nvSpPr>
+          <p:cNvPr id="2" name="Title 1"/>
+          <p:cNvSpPr>
+            <a:spLocks noGrp="1"/>
+          </p:cNvSpPr>
+          <p:nvPr>
+            <p:ph type="title"/>
+          </p:nvPr>
+        </p:nvSpPr>
+        <p:spPr/>
+        <p:txBody>
+          <a:bodyPr/>
+          <a:lstStyle/>
+          <a:p>
+            <a:r>
+              <a:t>Shared Resource Capacity - Vessels</a:t>
+            </a:r>
+          </a:p>
+        </p:txBody>
+      </p:sp>
+      <p:pic>
+        <p:nvPicPr>
+          <p:cNvPr id="3" name="Picture 2" descr="image.png"/>
+          <p:cNvPicPr>
+            <a:picLocks noChangeAspect="1"/>
+          </p:cNvPicPr>
+          <p:nvPr/>
+        </p:nvPicPr>
+        <p:blipFill>
+          <a:blip r:embed="rId2"/>
+          <a:stretch>
+            <a:fillRect/>
+          </a:stretch>
+        </p:blipFill>
+        <p:spPr>
+          <a:xfrm>
+            <a:off x="0" y="566928"/>
+            <a:ext cx="3886200" cy="7906543"/>
+          </a:xfrm>
+          <a:prstGeom prst="rect">
+            <a:avLst/>
+          </a:prstGeom>
+        </p:spPr>
+      </p:pic>
+    </p:spTree>
+  </p:cSld>
+  <p:clrMapOvr>
+    <a:masterClrMapping/>
+  </p:clrMapOvr>
+</p:sld>
+</file>
+
+<file path=ppt/slides/slide31.xml><?xml version="1.0" encoding="utf-8"?>
+<p:sld xmlns:a="http://schemas.openxmlformats.org/drawingml/2006/main" xmlns:p="http://schemas.openxmlformats.org/presentationml/2006/main" xmlns:r="http://schemas.openxmlformats.org/officeDocument/2006/relationships">
+  <p:cSld>
+    <p:spTree>
+      <p:nvGrpSpPr>
+        <p:cNvPr id="1" name=""/>
+        <p:cNvGrpSpPr/>
+        <p:nvPr/>
+      </p:nvGrpSpPr>
+      <p:grpSpPr/>
+      <p:sp>
+        <p:nvSpPr>
+          <p:cNvPr id="2" name="Title 1"/>
+          <p:cNvSpPr>
+            <a:spLocks noGrp="1"/>
+          </p:cNvSpPr>
+          <p:nvPr>
+            <p:ph type="title"/>
+          </p:nvPr>
+        </p:nvSpPr>
+        <p:spPr/>
+        <p:txBody>
+          <a:bodyPr/>
+          <a:lstStyle/>
+          <a:p>
+            <a:r>
+              <a:t>Shared Resource Capacity - Ports</a:t>
+            </a:r>
+          </a:p>
+        </p:txBody>
+      </p:sp>
+      <p:pic>
+        <p:nvPicPr>
+          <p:cNvPr id="3" name="Picture 2" descr="image.png"/>
+          <p:cNvPicPr>
+            <a:picLocks noChangeAspect="1"/>
+          </p:cNvPicPr>
+          <p:nvPr/>
+        </p:nvPicPr>
+        <p:blipFill>
+          <a:blip r:embed="rId2"/>
+          <a:stretch>
+            <a:fillRect/>
+          </a:stretch>
+        </p:blipFill>
+        <p:spPr>
+          <a:xfrm>
+            <a:off x="0" y="566928"/>
+            <a:ext cx="3886200" cy="7906543"/>
+          </a:xfrm>
+          <a:prstGeom prst="rect">
+            <a:avLst/>
+          </a:prstGeom>
+        </p:spPr>
+      </p:pic>
+    </p:spTree>
+  </p:cSld>
+  <p:clrMapOvr>
+    <a:masterClrMapping/>
+  </p:clrMapOvr>
+</p:sld>
+</file>
+
+<file path=ppt/slides/slide32.xml><?xml version="1.0" encoding="utf-8"?>
+<p:sld xmlns:a="http://schemas.openxmlformats.org/drawingml/2006/main" xmlns:p="http://schemas.openxmlformats.org/presentationml/2006/main" xmlns:r="http://schemas.openxmlformats.org/officeDocument/2006/relationships">
+  <p:cSld>
+    <p:spTree>
+      <p:nvGrpSpPr>
+        <p:cNvPr id="1" name=""/>
+        <p:cNvGrpSpPr/>
+        <p:nvPr/>
+      </p:nvGrpSpPr>
+      <p:grpSpPr/>
+      <p:sp>
+        <p:nvSpPr>
+          <p:cNvPr id="2" name="Title 1"/>
+          <p:cNvSpPr>
+            <a:spLocks noGrp="1"/>
+          </p:cNvSpPr>
+          <p:nvPr>
+            <p:ph type="title"/>
+          </p:nvPr>
+        </p:nvSpPr>
+        <p:spPr/>
+        <p:txBody>
+          <a:bodyPr/>
+          <a:lstStyle/>
+          <a:p>
+            <a:r>
+              <a:t>Full Gantt</a:t>
+            </a:r>
+          </a:p>
+        </p:txBody>
+      </p:sp>
+      <p:pic>
+        <p:nvPicPr>
+          <p:cNvPr id="3" name="Picture 2" descr="image.png"/>
+          <p:cNvPicPr>
+            <a:picLocks noChangeAspect="1"/>
+          </p:cNvPicPr>
+          <p:nvPr/>
+        </p:nvPicPr>
+        <p:blipFill>
+          <a:blip r:embed="rId2"/>
+          <a:stretch>
+            <a:fillRect/>
+          </a:stretch>
+        </p:blipFill>
+        <p:spPr>
+          <a:xfrm>
+            <a:off x="0" y="566928"/>
+            <a:ext cx="3886200" cy="3917501"/>
+          </a:xfrm>
+          <a:prstGeom prst="rect">
+            <a:avLst/>
+          </a:prstGeom>
+        </p:spPr>
+      </p:pic>
+    </p:spTree>
+  </p:cSld>
+  <p:clrMapOvr>
+    <a:masterClrMapping/>
+  </p:clrMapOvr>
+</p:sld>
+</file>
+
+<file path=ppt/slides/slide33.xml><?xml version="1.0" encoding="utf-8"?>
+<p:sld xmlns:a="http://schemas.openxmlformats.org/drawingml/2006/main" xmlns:p="http://schemas.openxmlformats.org/presentationml/2006/main" xmlns:r="http://schemas.openxmlformats.org/officeDocument/2006/relationships">
+  <p:cSld>
+    <p:spTree>
+      <p:nvGrpSpPr>
+        <p:cNvPr id="1" name=""/>
+        <p:cNvGrpSpPr/>
+        <p:nvPr/>
+      </p:nvGrpSpPr>
+      <p:grpSpPr/>
+      <p:sp>
+        <p:nvSpPr>
+          <p:cNvPr id="2" name="Title 1"/>
+          <p:cNvSpPr>
+            <a:spLocks noGrp="1"/>
+          </p:cNvSpPr>
+          <p:nvPr>
+            <p:ph type="title"/>
+          </p:nvPr>
+        </p:nvSpPr>
+        <p:spPr/>
+        <p:txBody>
+          <a:bodyPr/>
+          <a:lstStyle/>
+          <a:p>
+            <a:r>
+              <a:t>Sorted Full Gantt</a:t>
+            </a:r>
+          </a:p>
+        </p:txBody>
+      </p:sp>
+      <p:pic>
+        <p:nvPicPr>
+          <p:cNvPr id="3" name="Picture 2" descr="image.png"/>
+          <p:cNvPicPr>
+            <a:picLocks noChangeAspect="1"/>
+          </p:cNvPicPr>
+          <p:nvPr/>
+        </p:nvPicPr>
+        <p:blipFill>
+          <a:blip r:embed="rId2"/>
+          <a:stretch>
+            <a:fillRect/>
+          </a:stretch>
+        </p:blipFill>
+        <p:spPr>
+          <a:xfrm>
+            <a:off x="0" y="566928"/>
+            <a:ext cx="4800600" cy="4839267"/>
+          </a:xfrm>
+          <a:prstGeom prst="rect">
+            <a:avLst/>
+          </a:prstGeom>
+        </p:spPr>
+      </p:pic>
+    </p:spTree>
+  </p:cSld>
+  <p:clrMapOvr>
+    <a:masterClrMapping/>
+  </p:clrMapOvr>
+</p:sld>
+</file>
+
+<file path=ppt/slides/slide34.xml><?xml version="1.0" encoding="utf-8"?>
+<p:sld xmlns:a="http://schemas.openxmlformats.org/drawingml/2006/main" xmlns:p="http://schemas.openxmlformats.org/presentationml/2006/main" xmlns:r="http://schemas.openxmlformats.org/officeDocument/2006/relationships">
+  <p:cSld>
+    <p:spTree>
+      <p:nvGrpSpPr>
+        <p:cNvPr id="1" name=""/>
+        <p:cNvGrpSpPr/>
+        <p:nvPr/>
+      </p:nvGrpSpPr>
+      <p:grpSpPr/>
+      <p:sp>
+        <p:nvSpPr>
+          <p:cNvPr id="2" name="Title 1"/>
+          <p:cNvSpPr>
+            <a:spLocks noGrp="1"/>
+          </p:cNvSpPr>
+          <p:nvPr>
+            <p:ph type="title"/>
+          </p:nvPr>
+        </p:nvSpPr>
+        <p:spPr/>
+        <p:txBody>
+          <a:bodyPr/>
+          <a:lstStyle/>
+          <a:p>
+            <a:r>
+              <a:t>New England Gantt</a:t>
+            </a:r>
+          </a:p>
+        </p:txBody>
+      </p:sp>
+      <p:pic>
+        <p:nvPicPr>
+          <p:cNvPr id="3" name="Picture 2" descr="image.png"/>
+          <p:cNvPicPr>
+            <a:picLocks noChangeAspect="1"/>
+          </p:cNvPicPr>
+          <p:nvPr/>
+        </p:nvPicPr>
+        <p:blipFill>
+          <a:blip r:embed="rId2"/>
+          <a:stretch>
+            <a:fillRect/>
+          </a:stretch>
+        </p:blipFill>
+        <p:spPr>
+          <a:xfrm>
+            <a:off x="0" y="566928"/>
+            <a:ext cx="12188952" cy="4149777"/>
+          </a:xfrm>
+          <a:prstGeom prst="rect">
+            <a:avLst/>
+          </a:prstGeom>
+        </p:spPr>
+      </p:pic>
+    </p:spTree>
+  </p:cSld>
+  <p:clrMapOvr>
+    <a:masterClrMapping/>
+  </p:clrMapOvr>
+</p:sld>
+</file>
+
+<file path=ppt/slides/slide35.xml><?xml version="1.0" encoding="utf-8"?>
+<p:sld xmlns:a="http://schemas.openxmlformats.org/drawingml/2006/main" xmlns:p="http://schemas.openxmlformats.org/presentationml/2006/main" xmlns:r="http://schemas.openxmlformats.org/officeDocument/2006/relationships">
+  <p:cSld>
+    <p:spTree>
+      <p:nvGrpSpPr>
+        <p:cNvPr id="1" name=""/>
+        <p:cNvGrpSpPr/>
+        <p:nvPr/>
+      </p:nvGrpSpPr>
+      <p:grpSpPr/>
+      <p:sp>
+        <p:nvSpPr>
+          <p:cNvPr id="2" name="Title 1"/>
+          <p:cNvSpPr>
+            <a:spLocks noGrp="1"/>
+          </p:cNvSpPr>
+          <p:nvPr>
+            <p:ph type="title"/>
+          </p:nvPr>
+        </p:nvSpPr>
+        <p:spPr/>
+        <p:txBody>
+          <a:bodyPr/>
+          <a:lstStyle/>
+          <a:p>
+            <a:r>
+              <a:t>Sorted New England Gantt</a:t>
+            </a:r>
+          </a:p>
+        </p:txBody>
+      </p:sp>
+      <p:pic>
+        <p:nvPicPr>
+          <p:cNvPr id="3" name="Picture 2" descr="image.png"/>
+          <p:cNvPicPr>
+            <a:picLocks noChangeAspect="1"/>
+          </p:cNvPicPr>
+          <p:nvPr/>
+        </p:nvPicPr>
+        <p:blipFill>
+          <a:blip r:embed="rId2"/>
+          <a:stretch>
+            <a:fillRect/>
+          </a:stretch>
+        </p:blipFill>
+        <p:spPr>
+          <a:xfrm>
+            <a:off x="0" y="566928"/>
+            <a:ext cx="12188952" cy="4149777"/>
+          </a:xfrm>
+          <a:prstGeom prst="rect">
+            <a:avLst/>
+          </a:prstGeom>
+        </p:spPr>
+      </p:pic>
+    </p:spTree>
+  </p:cSld>
+  <p:clrMapOvr>
+    <a:masterClrMapping/>
+  </p:clrMapOvr>
+</p:sld>
+</file>
+
+<file path=ppt/slides/slide36.xml><?xml version="1.0" encoding="utf-8"?>
+<p:sld xmlns:a="http://schemas.openxmlformats.org/drawingml/2006/main" xmlns:p="http://schemas.openxmlformats.org/presentationml/2006/main" xmlns:r="http://schemas.openxmlformats.org/officeDocument/2006/relationships">
+  <p:cSld>
+    <p:spTree>
+      <p:nvGrpSpPr>
+        <p:cNvPr id="1" name=""/>
+        <p:cNvGrpSpPr/>
+        <p:nvPr/>
+      </p:nvGrpSpPr>
+      <p:grpSpPr/>
+      <p:sp>
+        <p:nvSpPr>
+          <p:cNvPr id="2" name="Title 1"/>
+          <p:cNvSpPr>
+            <a:spLocks noGrp="1"/>
+          </p:cNvSpPr>
+          <p:nvPr>
+            <p:ph type="title"/>
+          </p:nvPr>
+        </p:nvSpPr>
+        <p:spPr/>
+        <p:txBody>
+          <a:bodyPr/>
+          <a:lstStyle/>
+          <a:p>
+            <a:r>
+              <a:t>Fixed Gantt</a:t>
+            </a:r>
+          </a:p>
+        </p:txBody>
+      </p:sp>
+      <p:pic>
+        <p:nvPicPr>
+          <p:cNvPr id="3" name="Picture 2" descr="image.png"/>
+          <p:cNvPicPr>
+            <a:picLocks noChangeAspect="1"/>
+          </p:cNvPicPr>
+          <p:nvPr/>
+        </p:nvPicPr>
+        <p:blipFill>
+          <a:blip r:embed="rId2"/>
+          <a:stretch>
+            <a:fillRect/>
+          </a:stretch>
+        </p:blipFill>
+        <p:spPr>
+          <a:xfrm>
+            <a:off x="0" y="566928"/>
+            <a:ext cx="12188952" cy="10829589"/>
+          </a:xfrm>
+          <a:prstGeom prst="rect">
+            <a:avLst/>
+          </a:prstGeom>
+        </p:spPr>
+      </p:pic>
+    </p:spTree>
+  </p:cSld>
+  <p:clrMapOvr>
+    <a:masterClrMapping/>
+  </p:clrMapOvr>
+</p:sld>
+</file>
+
+<file path=ppt/slides/slide37.xml><?xml version="1.0" encoding="utf-8"?>
+<p:sld xmlns:a="http://schemas.openxmlformats.org/drawingml/2006/main" xmlns:p="http://schemas.openxmlformats.org/presentationml/2006/main" xmlns:r="http://schemas.openxmlformats.org/officeDocument/2006/relationships">
+  <p:cSld>
+    <p:spTree>
+      <p:nvGrpSpPr>
+        <p:cNvPr id="1" name=""/>
+        <p:cNvGrpSpPr/>
+        <p:nvPr/>
+      </p:nvGrpSpPr>
+      <p:grpSpPr/>
+      <p:sp>
+        <p:nvSpPr>
+          <p:cNvPr id="2" name="Title 1"/>
+          <p:cNvSpPr>
+            <a:spLocks noGrp="1"/>
+          </p:cNvSpPr>
+          <p:nvPr>
+            <p:ph type="title"/>
+          </p:nvPr>
+        </p:nvSpPr>
+        <p:spPr/>
+        <p:txBody>
+          <a:bodyPr/>
+          <a:lstStyle/>
+          <a:p>
+            <a:r>
+              <a:t>Sorted Fixed Gantt</a:t>
+            </a:r>
+          </a:p>
+        </p:txBody>
+      </p:sp>
+      <p:pic>
+        <p:nvPicPr>
+          <p:cNvPr id="3" name="Picture 2" descr="image.png"/>
+          <p:cNvPicPr>
+            <a:picLocks noChangeAspect="1"/>
+          </p:cNvPicPr>
+          <p:nvPr/>
+        </p:nvPicPr>
+        <p:blipFill>
+          <a:blip r:embed="rId2"/>
+          <a:stretch>
+            <a:fillRect/>
+          </a:stretch>
+        </p:blipFill>
+        <p:spPr>
+          <a:xfrm>
+            <a:off x="0" y="566928"/>
+            <a:ext cx="12188952" cy="10829589"/>
+          </a:xfrm>
+          <a:prstGeom prst="rect">
+            <a:avLst/>
+          </a:prstGeom>
+        </p:spPr>
+      </p:pic>
+    </p:spTree>
+  </p:cSld>
+  <p:clrMapOvr>
+    <a:masterClrMapping/>
+  </p:clrMapOvr>
+</p:sld>
+</file>
+
+<file path=ppt/slides/slide38.xml><?xml version="1.0" encoding="utf-8"?>
+<p:sld xmlns:a="http://schemas.openxmlformats.org/drawingml/2006/main" xmlns:p="http://schemas.openxmlformats.org/presentationml/2006/main" xmlns:r="http://schemas.openxmlformats.org/officeDocument/2006/relationships">
+  <p:cSld>
+    <p:spTree>
+      <p:nvGrpSpPr>
+        <p:cNvPr id="1" name=""/>
+        <p:cNvGrpSpPr/>
+        <p:nvPr/>
+      </p:nvGrpSpPr>
+      <p:grpSpPr/>
+      <p:sp>
+        <p:nvSpPr>
+          <p:cNvPr id="2" name="Title 1"/>
+          <p:cNvSpPr>
+            <a:spLocks noGrp="1"/>
+          </p:cNvSpPr>
+          <p:nvPr>
+            <p:ph type="title"/>
+          </p:nvPr>
+        </p:nvSpPr>
+        <p:spPr/>
+        <p:txBody>
+          <a:bodyPr/>
+          <a:lstStyle/>
+          <a:p>
+            <a:r>
+              <a:t>Floating Gantt</a:t>
+            </a:r>
+          </a:p>
+        </p:txBody>
+      </p:sp>
+      <p:pic>
+        <p:nvPicPr>
+          <p:cNvPr id="3" name="Picture 2" descr="image.png"/>
+          <p:cNvPicPr>
+            <a:picLocks noChangeAspect="1"/>
+          </p:cNvPicPr>
+          <p:nvPr/>
+        </p:nvPicPr>
+        <p:blipFill>
+          <a:blip r:embed="rId2"/>
+          <a:stretch>
+            <a:fillRect/>
+          </a:stretch>
+        </p:blipFill>
+        <p:spPr>
+          <a:xfrm>
+            <a:off x="0" y="566928"/>
+            <a:ext cx="12188952" cy="1658026"/>
+          </a:xfrm>
+          <a:prstGeom prst="rect">
+            <a:avLst/>
+          </a:prstGeom>
+        </p:spPr>
+      </p:pic>
+    </p:spTree>
+  </p:cSld>
+  <p:clrMapOvr>
+    <a:masterClrMapping/>
+  </p:clrMapOvr>
+</p:sld>
+</file>
+
+<file path=ppt/slides/slide39.xml><?xml version="1.0" encoding="utf-8"?>
+<p:sld xmlns:a="http://schemas.openxmlformats.org/drawingml/2006/main" xmlns:p="http://schemas.openxmlformats.org/presentationml/2006/main" xmlns:r="http://schemas.openxmlformats.org/officeDocument/2006/relationships">
+  <p:cSld>
+    <p:spTree>
+      <p:nvGrpSpPr>
+        <p:cNvPr id="1" name=""/>
+        <p:cNvGrpSpPr/>
+        <p:nvPr/>
+      </p:nvGrpSpPr>
+      <p:grpSpPr/>
+      <p:sp>
+        <p:nvSpPr>
+          <p:cNvPr id="2" name="Title 1"/>
+          <p:cNvSpPr>
+            <a:spLocks noGrp="1"/>
+          </p:cNvSpPr>
+          <p:nvPr>
+            <p:ph type="title"/>
+          </p:nvPr>
+        </p:nvSpPr>
+        <p:spPr/>
+        <p:txBody>
+          <a:bodyPr/>
+          <a:lstStyle/>
+          <a:p>
+            <a:r>
+              <a:t>Sorted Floating Gantt</a:t>
+            </a:r>
+          </a:p>
+        </p:txBody>
+      </p:sp>
+      <p:pic>
+        <p:nvPicPr>
+          <p:cNvPr id="3" name="Picture 2" descr="image.png"/>
+          <p:cNvPicPr>
+            <a:picLocks noChangeAspect="1"/>
+          </p:cNvPicPr>
+          <p:nvPr/>
+        </p:nvPicPr>
+        <p:blipFill>
+          <a:blip r:embed="rId2"/>
+          <a:stretch>
+            <a:fillRect/>
+          </a:stretch>
+        </p:blipFill>
+        <p:spPr>
+          <a:xfrm>
+            <a:off x="0" y="566928"/>
+            <a:ext cx="12188952" cy="1658026"/>
+          </a:xfrm>
+          <a:prstGeom prst="rect">
+            <a:avLst/>
+          </a:prstGeom>
+        </p:spPr>
+      </p:pic>
+    </p:spTree>
+  </p:cSld>
+  <p:clrMapOvr>
+    <a:masterClrMapping/>
+  </p:clrMapOvr>
+</p:sld>
+</file>
+
+<file path=ppt/slides/slide4.xml><?xml version="1.0" encoding="utf-8"?>
+<p:sld xmlns:a="http://schemas.openxmlformats.org/drawingml/2006/main" xmlns:p="http://schemas.openxmlformats.org/presentationml/2006/main" xmlns:r="http://schemas.openxmlformats.org/officeDocument/2006/relationships">
+  <p:cSld>
+    <p:spTree>
+      <p:nvGrpSpPr>
+        <p:cNvPr id="1" name=""/>
+        <p:cNvGrpSpPr/>
+        <p:nvPr/>
+      </p:nvGrpSpPr>
+      <p:grpSpPr/>
+      <p:sp>
+        <p:nvSpPr>
+          <p:cNvPr id="2" name="Title 1"/>
+          <p:cNvSpPr>
+            <a:spLocks noGrp="1"/>
+          </p:cNvSpPr>
+          <p:nvPr>
+            <p:ph type="title"/>
+          </p:nvPr>
+        </p:nvSpPr>
+        <p:spPr/>
+        <p:txBody>
+          <a:bodyPr/>
+          <a:lstStyle/>
+          <a:p>
+            <a:r>
+              <a:t>Full Gantt</a:t>
+            </a:r>
+          </a:p>
+        </p:txBody>
+      </p:sp>
+      <p:pic>
+        <p:nvPicPr>
+          <p:cNvPr id="3" name="Picture 2" descr="image.png"/>
+          <p:cNvPicPr>
+            <a:picLocks noChangeAspect="1"/>
+          </p:cNvPicPr>
+          <p:nvPr/>
+        </p:nvPicPr>
+        <p:blipFill>
+          <a:blip r:embed="rId2"/>
+          <a:stretch>
+            <a:fillRect/>
+          </a:stretch>
+        </p:blipFill>
+        <p:spPr>
+          <a:xfrm>
+            <a:off x="0" y="566928"/>
             <a:ext cx="3886200" cy="3924797"/>
+          </a:xfrm>
+          <a:prstGeom prst="rect">
+            <a:avLst/>
+          </a:prstGeom>
+        </p:spPr>
+      </p:pic>
+    </p:spTree>
+  </p:cSld>
+  <p:clrMapOvr>
+    <a:masterClrMapping/>
+  </p:clrMapOvr>
+</p:sld>
+</file>
+
+<file path=ppt/slides/slide40.xml><?xml version="1.0" encoding="utf-8"?>
+<p:sld xmlns:a="http://schemas.openxmlformats.org/drawingml/2006/main" xmlns:p="http://schemas.openxmlformats.org/presentationml/2006/main" xmlns:r="http://schemas.openxmlformats.org/officeDocument/2006/relationships">
+  <p:cSld>
+    <p:spTree>
+      <p:nvGrpSpPr>
+        <p:cNvPr id="1" name=""/>
+        <p:cNvGrpSpPr/>
+        <p:nvPr/>
+      </p:nvGrpSpPr>
+      <p:grpSpPr/>
+      <p:sp>
+        <p:nvSpPr>
+          <p:cNvPr id="2" name="Title 1"/>
+          <p:cNvSpPr>
+            <a:spLocks noGrp="1"/>
+          </p:cNvSpPr>
+          <p:nvPr>
+            <p:ph type="title"/>
+          </p:nvPr>
+        </p:nvSpPr>
+        <p:spPr/>
+        <p:txBody>
+          <a:bodyPr/>
+          <a:lstStyle/>
+          <a:p>
+            <a:r>
+              <a:t>Vessel Utilization</a:t>
+            </a:r>
+          </a:p>
+        </p:txBody>
+      </p:sp>
+      <p:pic>
+        <p:nvPicPr>
+          <p:cNvPr id="3" name="Picture 2" descr="image.png"/>
+          <p:cNvPicPr>
+            <a:picLocks noChangeAspect="1"/>
+          </p:cNvPicPr>
+          <p:nvPr/>
+        </p:nvPicPr>
+        <p:blipFill>
+          <a:blip r:embed="rId2"/>
+          <a:stretch>
+            <a:fillRect/>
+          </a:stretch>
+        </p:blipFill>
+        <p:spPr>
+          <a:xfrm>
+            <a:off x="0" y="566928"/>
+            <a:ext cx="12188952" cy="8650224"/>
+          </a:xfrm>
+          <a:prstGeom prst="rect">
+            <a:avLst/>
+          </a:prstGeom>
+        </p:spPr>
+      </p:pic>
+    </p:spTree>
+  </p:cSld>
+  <p:clrMapOvr>
+    <a:masterClrMapping/>
+  </p:clrMapOvr>
+</p:sld>
+</file>
+
+<file path=ppt/slides/slide41.xml><?xml version="1.0" encoding="utf-8"?>
+<p:sld xmlns:a="http://schemas.openxmlformats.org/drawingml/2006/main" xmlns:p="http://schemas.openxmlformats.org/presentationml/2006/main" xmlns:r="http://schemas.openxmlformats.org/officeDocument/2006/relationships">
+  <p:cSld>
+    <p:spTree>
+      <p:nvGrpSpPr>
+        <p:cNvPr id="1" name=""/>
+        <p:cNvGrpSpPr/>
+        <p:nvPr/>
+      </p:nvGrpSpPr>
+      <p:grpSpPr/>
+      <p:sp>
+        <p:nvSpPr>
+          <p:cNvPr id="2" name="Title 1"/>
+          <p:cNvSpPr>
+            <a:spLocks noGrp="1"/>
+          </p:cNvSpPr>
+          <p:nvPr>
+            <p:ph type="title"/>
+          </p:nvPr>
+        </p:nvSpPr>
+        <p:spPr/>
+        <p:txBody>
+          <a:bodyPr/>
+          <a:lstStyle/>
+          <a:p>
+            <a:r>
+              <a:t>Port Throughput</a:t>
+            </a:r>
+          </a:p>
+        </p:txBody>
+      </p:sp>
+      <p:pic>
+        <p:nvPicPr>
+          <p:cNvPr id="3" name="Picture 2" descr="image.png"/>
+          <p:cNvPicPr>
+            <a:picLocks noChangeAspect="1"/>
+          </p:cNvPicPr>
+          <p:nvPr/>
+        </p:nvPicPr>
+        <p:blipFill>
+          <a:blip r:embed="rId2"/>
+          <a:stretch>
+            <a:fillRect/>
+          </a:stretch>
+        </p:blipFill>
+        <p:spPr>
+          <a:xfrm>
+            <a:off x="0" y="566928"/>
+            <a:ext cx="12188952" cy="8228396"/>
+          </a:xfrm>
+          <a:prstGeom prst="rect">
+            <a:avLst/>
+          </a:prstGeom>
+        </p:spPr>
+      </p:pic>
+    </p:spTree>
+  </p:cSld>
+  <p:clrMapOvr>
+    <a:masterClrMapping/>
+  </p:clrMapOvr>
+</p:sld>
+</file>
+
+<file path=ppt/slides/slide42.xml><?xml version="1.0" encoding="utf-8"?>
+<p:sld xmlns:a="http://schemas.openxmlformats.org/drawingml/2006/main" xmlns:p="http://schemas.openxmlformats.org/presentationml/2006/main" xmlns:r="http://schemas.openxmlformats.org/officeDocument/2006/relationships">
+  <p:cSld>
+    <p:spTree>
+      <p:nvGrpSpPr>
+        <p:cNvPr id="1" name=""/>
+        <p:cNvGrpSpPr/>
+        <p:nvPr/>
+      </p:nvGrpSpPr>
+      <p:grpSpPr/>
+      <p:sp>
+        <p:nvSpPr>
+          <p:cNvPr id="2" name="Title 1"/>
+          <p:cNvSpPr>
+            <a:spLocks noGrp="1"/>
+          </p:cNvSpPr>
+          <p:nvPr>
+            <p:ph type="title"/>
+          </p:nvPr>
+        </p:nvSpPr>
+        <p:spPr/>
+        <p:txBody>
+          <a:bodyPr/>
+          <a:lstStyle/>
+          <a:p>
+            <a:r>
+              <a:t>Port Throughput</a:t>
+            </a:r>
+          </a:p>
+        </p:txBody>
+      </p:sp>
+      <p:pic>
+        <p:nvPicPr>
+          <p:cNvPr id="3" name="Picture 2" descr="image.png"/>
+          <p:cNvPicPr>
+            <a:picLocks noChangeAspect="1"/>
+          </p:cNvPicPr>
+          <p:nvPr/>
+        </p:nvPicPr>
+        <p:blipFill>
+          <a:blip r:embed="rId2"/>
+          <a:stretch>
+            <a:fillRect/>
+          </a:stretch>
+        </p:blipFill>
+        <p:spPr>
+          <a:xfrm>
+            <a:off x="0" y="566928"/>
+            <a:ext cx="12188952" cy="8228396"/>
+          </a:xfrm>
+          <a:prstGeom prst="rect">
+            <a:avLst/>
+          </a:prstGeom>
+        </p:spPr>
+      </p:pic>
+    </p:spTree>
+  </p:cSld>
+  <p:clrMapOvr>
+    <a:masterClrMapping/>
+  </p:clrMapOvr>
+</p:sld>
+</file>
+
+<file path=ppt/slides/slide43.xml><?xml version="1.0" encoding="utf-8"?>
+<p:sld xmlns:a="http://schemas.openxmlformats.org/drawingml/2006/main" xmlns:p="http://schemas.openxmlformats.org/presentationml/2006/main" xmlns:r="http://schemas.openxmlformats.org/officeDocument/2006/relationships">
+  <p:cSld>
+    <p:spTree>
+      <p:nvGrpSpPr>
+        <p:cNvPr id="1" name=""/>
+        <p:cNvGrpSpPr/>
+        <p:nvPr/>
+      </p:nvGrpSpPr>
+      <p:grpSpPr/>
+      <p:sp>
+        <p:nvSpPr>
+          <p:cNvPr id="2" name="Text Placeholder 1"/>
+          <p:cNvSpPr>
+            <a:spLocks noGrp="1"/>
+          </p:cNvSpPr>
+          <p:nvPr>
+            <p:ph type="body" idx="10" sz="quarter"/>
+          </p:nvPr>
+        </p:nvSpPr>
+        <p:spPr/>
+        <p:txBody>
+          <a:bodyPr/>
+          <a:lstStyle/>
+          <a:p>
+            <a:r>
+              <a:t>Summary Plots</a:t>
+            </a:r>
+          </a:p>
+        </p:txBody>
+      </p:sp>
+      <p:sp>
+        <p:nvSpPr>
+          <p:cNvPr id="3" name="Text Placeholder 2"/>
+          <p:cNvSpPr>
+            <a:spLocks noGrp="1"/>
+          </p:cNvSpPr>
+          <p:nvPr>
+            <p:ph type="body" idx="11" sz="quarter"/>
+          </p:nvPr>
+        </p:nvSpPr>
+        <p:spPr/>
+        <p:txBody>
+          <a:bodyPr/>
+          <a:lstStyle/>
+          <a:p/>
+        </p:txBody>
+      </p:sp>
+    </p:spTree>
+  </p:cSld>
+  <p:clrMapOvr>
+    <a:masterClrMapping/>
+  </p:clrMapOvr>
+</p:sld>
+</file>
+
+<file path=ppt/slides/slide44.xml><?xml version="1.0" encoding="utf-8"?>
+<p:sld xmlns:a="http://schemas.openxmlformats.org/drawingml/2006/main" xmlns:p="http://schemas.openxmlformats.org/presentationml/2006/main" xmlns:r="http://schemas.openxmlformats.org/officeDocument/2006/relationships">
+  <p:cSld>
+    <p:spTree>
+      <p:nvGrpSpPr>
+        <p:cNvPr id="1" name=""/>
+        <p:cNvGrpSpPr/>
+        <p:nvPr/>
+      </p:nvGrpSpPr>
+      <p:grpSpPr/>
+      <p:sp>
+        <p:nvSpPr>
+          <p:cNvPr id="2" name="Title 1"/>
+          <p:cNvSpPr>
+            <a:spLocks noGrp="1"/>
+          </p:cNvSpPr>
+          <p:nvPr>
+            <p:ph type="title"/>
+          </p:nvPr>
+        </p:nvSpPr>
+        <p:spPr/>
+        <p:txBody>
+          <a:bodyPr/>
+          <a:lstStyle/>
+          <a:p>
+            <a:r>
+              <a:t>Cumulative Installed Capacity</a:t>
+            </a:r>
+          </a:p>
+        </p:txBody>
+      </p:sp>
+      <p:pic>
+        <p:nvPicPr>
+          <p:cNvPr id="3" name="Picture 2" descr="image.png"/>
+          <p:cNvPicPr>
+            <a:picLocks noChangeAspect="1"/>
+          </p:cNvPicPr>
+          <p:nvPr/>
+        </p:nvPicPr>
+        <p:blipFill>
+          <a:blip r:embed="rId2"/>
+          <a:stretch>
+            <a:fillRect/>
+          </a:stretch>
+        </p:blipFill>
+        <p:spPr>
+          <a:xfrm>
+            <a:off x="0" y="566928"/>
+            <a:ext cx="12188952" cy="5091404"/>
+          </a:xfrm>
+          <a:prstGeom prst="rect">
+            <a:avLst/>
+          </a:prstGeom>
+        </p:spPr>
+      </p:pic>
+    </p:spTree>
+  </p:cSld>
+  <p:clrMapOvr>
+    <a:masterClrMapping/>
+  </p:clrMapOvr>
+</p:sld>
+</file>
+
+<file path=ppt/slides/slide45.xml><?xml version="1.0" encoding="utf-8"?>
+<p:sld xmlns:a="http://schemas.openxmlformats.org/drawingml/2006/main" xmlns:p="http://schemas.openxmlformats.org/presentationml/2006/main" xmlns:r="http://schemas.openxmlformats.org/officeDocument/2006/relationships">
+  <p:cSld>
+    <p:spTree>
+      <p:nvGrpSpPr>
+        <p:cNvPr id="1" name=""/>
+        <p:cNvGrpSpPr/>
+        <p:nvPr/>
+      </p:nvGrpSpPr>
+      <p:grpSpPr/>
+      <p:sp>
+        <p:nvSpPr>
+          <p:cNvPr id="2" name="Title 1"/>
+          <p:cNvSpPr>
+            <a:spLocks noGrp="1"/>
+          </p:cNvSpPr>
+          <p:nvPr>
+            <p:ph type="title"/>
+          </p:nvPr>
+        </p:nvSpPr>
+        <p:spPr/>
+        <p:txBody>
+          <a:bodyPr/>
+          <a:lstStyle/>
+          <a:p>
+            <a:r>
+              <a:t>Summary Installed Capacity</a:t>
+            </a:r>
+          </a:p>
+        </p:txBody>
+      </p:sp>
+      <p:pic>
+        <p:nvPicPr>
+          <p:cNvPr id="3" name="Picture 2" descr="image.png"/>
+          <p:cNvPicPr>
+            <a:picLocks noChangeAspect="1"/>
+          </p:cNvPicPr>
+          <p:nvPr/>
+        </p:nvPicPr>
+        <p:blipFill>
+          <a:blip r:embed="rId2"/>
+          <a:stretch>
+            <a:fillRect/>
+          </a:stretch>
+        </p:blipFill>
+        <p:spPr>
+          <a:xfrm>
+            <a:off x="0" y="566928"/>
+            <a:ext cx="12188952" cy="8072457"/>
+          </a:xfrm>
+          <a:prstGeom prst="rect">
+            <a:avLst/>
+          </a:prstGeom>
+        </p:spPr>
+      </p:pic>
+    </p:spTree>
+  </p:cSld>
+  <p:clrMapOvr>
+    <a:masterClrMapping/>
+  </p:clrMapOvr>
+</p:sld>
+</file>
+
+<file path=ppt/slides/slide46.xml><?xml version="1.0" encoding="utf-8"?>
+<p:sld xmlns:a="http://schemas.openxmlformats.org/drawingml/2006/main" xmlns:p="http://schemas.openxmlformats.org/presentationml/2006/main" xmlns:r="http://schemas.openxmlformats.org/officeDocument/2006/relationships">
+  <p:cSld>
+    <p:spTree>
+      <p:nvGrpSpPr>
+        <p:cNvPr id="1" name=""/>
+        <p:cNvGrpSpPr/>
+        <p:nvPr/>
+      </p:nvGrpSpPr>
+      <p:grpSpPr/>
+      <p:sp>
+        <p:nvSpPr>
+          <p:cNvPr id="2" name="Title 1"/>
+          <p:cNvSpPr>
+            <a:spLocks noGrp="1"/>
+          </p:cNvSpPr>
+          <p:nvPr>
+            <p:ph type="title"/>
+          </p:nvPr>
+        </p:nvSpPr>
+        <p:spPr/>
+        <p:txBody>
+          <a:bodyPr/>
+          <a:lstStyle/>
+          <a:p>
+            <a:r>
+              <a:t>Installed Capacity - All Regions</a:t>
+            </a:r>
+          </a:p>
+        </p:txBody>
+      </p:sp>
+      <p:pic>
+        <p:nvPicPr>
+          <p:cNvPr id="3" name="Picture 2" descr="image.png"/>
+          <p:cNvPicPr>
+            <a:picLocks noChangeAspect="1"/>
+          </p:cNvPicPr>
+          <p:nvPr/>
+        </p:nvPicPr>
+        <p:blipFill>
+          <a:blip r:embed="rId2"/>
+          <a:stretch>
+            <a:fillRect/>
+          </a:stretch>
+        </p:blipFill>
+        <p:spPr>
+          <a:xfrm>
+            <a:off x="0" y="566928"/>
+            <a:ext cx="12188952" cy="5062776"/>
+          </a:xfrm>
+          <a:prstGeom prst="rect">
+            <a:avLst/>
+          </a:prstGeom>
+        </p:spPr>
+      </p:pic>
+    </p:spTree>
+  </p:cSld>
+  <p:clrMapOvr>
+    <a:masterClrMapping/>
+  </p:clrMapOvr>
+</p:sld>
+</file>
+
+<file path=ppt/slides/slide47.xml><?xml version="1.0" encoding="utf-8"?>
+<p:sld xmlns:a="http://schemas.openxmlformats.org/drawingml/2006/main" xmlns:p="http://schemas.openxmlformats.org/presentationml/2006/main" xmlns:r="http://schemas.openxmlformats.org/officeDocument/2006/relationships">
+  <p:cSld>
+    <p:spTree>
+      <p:nvGrpSpPr>
+        <p:cNvPr id="1" name=""/>
+        <p:cNvGrpSpPr/>
+        <p:nvPr/>
+      </p:nvGrpSpPr>
+      <p:grpSpPr/>
+      <p:sp>
+        <p:nvSpPr>
+          <p:cNvPr id="2" name="Title 1"/>
+          <p:cNvSpPr>
+            <a:spLocks noGrp="1"/>
+          </p:cNvSpPr>
+          <p:nvPr>
+            <p:ph type="title"/>
+          </p:nvPr>
+        </p:nvSpPr>
+        <p:spPr/>
+        <p:txBody>
+          <a:bodyPr/>
+          <a:lstStyle/>
+          <a:p>
+            <a:r>
+              <a:t>Installed Capacity - NE</a:t>
+            </a:r>
+          </a:p>
+        </p:txBody>
+      </p:sp>
+      <p:pic>
+        <p:nvPicPr>
+          <p:cNvPr id="3" name="Picture 2" descr="image.png"/>
+          <p:cNvPicPr>
+            <a:picLocks noChangeAspect="1"/>
+          </p:cNvPicPr>
+          <p:nvPr/>
+        </p:nvPicPr>
+        <p:blipFill>
+          <a:blip r:embed="rId2"/>
+          <a:stretch>
+            <a:fillRect/>
+          </a:stretch>
+        </p:blipFill>
+        <p:spPr>
+          <a:xfrm>
+            <a:off x="0" y="566928"/>
+            <a:ext cx="12188952" cy="5062776"/>
+          </a:xfrm>
+          <a:prstGeom prst="rect">
+            <a:avLst/>
+          </a:prstGeom>
+        </p:spPr>
+      </p:pic>
+    </p:spTree>
+  </p:cSld>
+  <p:clrMapOvr>
+    <a:masterClrMapping/>
+  </p:clrMapOvr>
+</p:sld>
+</file>
+
+<file path=ppt/slides/slide48.xml><?xml version="1.0" encoding="utf-8"?>
+<p:sld xmlns:a="http://schemas.openxmlformats.org/drawingml/2006/main" xmlns:p="http://schemas.openxmlformats.org/presentationml/2006/main" xmlns:r="http://schemas.openxmlformats.org/officeDocument/2006/relationships">
+  <p:cSld>
+    <p:spTree>
+      <p:nvGrpSpPr>
+        <p:cNvPr id="1" name=""/>
+        <p:cNvGrpSpPr/>
+        <p:nvPr/>
+      </p:nvGrpSpPr>
+      <p:grpSpPr/>
+      <p:sp>
+        <p:nvSpPr>
+          <p:cNvPr id="2" name="Title 1"/>
+          <p:cNvSpPr>
+            <a:spLocks noGrp="1"/>
+          </p:cNvSpPr>
+          <p:nvPr>
+            <p:ph type="title"/>
+          </p:nvPr>
+        </p:nvSpPr>
+        <p:spPr/>
+        <p:txBody>
+          <a:bodyPr/>
+          <a:lstStyle/>
+          <a:p>
+            <a:r>
+              <a:t>Installed Capacity - NY/NJ</a:t>
+            </a:r>
+          </a:p>
+        </p:txBody>
+      </p:sp>
+      <p:pic>
+        <p:nvPicPr>
+          <p:cNvPr id="3" name="Picture 2" descr="image.png"/>
+          <p:cNvPicPr>
+            <a:picLocks noChangeAspect="1"/>
+          </p:cNvPicPr>
+          <p:nvPr/>
+        </p:nvPicPr>
+        <p:blipFill>
+          <a:blip r:embed="rId2"/>
+          <a:stretch>
+            <a:fillRect/>
+          </a:stretch>
+        </p:blipFill>
+        <p:spPr>
+          <a:xfrm>
+            <a:off x="0" y="566928"/>
+            <a:ext cx="12188952" cy="5062776"/>
+          </a:xfrm>
+          <a:prstGeom prst="rect">
+            <a:avLst/>
+          </a:prstGeom>
+        </p:spPr>
+      </p:pic>
+    </p:spTree>
+  </p:cSld>
+  <p:clrMapOvr>
+    <a:masterClrMapping/>
+  </p:clrMapOvr>
+</p:sld>
+</file>
+
+<file path=ppt/slides/slide49.xml><?xml version="1.0" encoding="utf-8"?>
+<p:sld xmlns:a="http://schemas.openxmlformats.org/drawingml/2006/main" xmlns:p="http://schemas.openxmlformats.org/presentationml/2006/main" xmlns:r="http://schemas.openxmlformats.org/officeDocument/2006/relationships">
+  <p:cSld>
+    <p:spTree>
+      <p:nvGrpSpPr>
+        <p:cNvPr id="1" name=""/>
+        <p:cNvGrpSpPr/>
+        <p:nvPr/>
+      </p:nvGrpSpPr>
+      <p:grpSpPr/>
+      <p:sp>
+        <p:nvSpPr>
+          <p:cNvPr id="2" name="Title 1"/>
+          <p:cNvSpPr>
+            <a:spLocks noGrp="1"/>
+          </p:cNvSpPr>
+          <p:nvPr>
+            <p:ph type="title"/>
+          </p:nvPr>
+        </p:nvSpPr>
+        <p:spPr/>
+        <p:txBody>
+          <a:bodyPr/>
+          <a:lstStyle/>
+          <a:p>
+            <a:r>
+              <a:t>Installed Capacity - Central Atlantic</a:t>
+            </a:r>
+          </a:p>
+        </p:txBody>
+      </p:sp>
+      <p:pic>
+        <p:nvPicPr>
+          <p:cNvPr id="3" name="Picture 2" descr="image.png"/>
+          <p:cNvPicPr>
+            <a:picLocks noChangeAspect="1"/>
+          </p:cNvPicPr>
+          <p:nvPr/>
+        </p:nvPicPr>
+        <p:blipFill>
+          <a:blip r:embed="rId2"/>
+          <a:stretch>
+            <a:fillRect/>
+          </a:stretch>
+        </p:blipFill>
+        <p:spPr>
+          <a:xfrm>
+            <a:off x="0" y="566928"/>
+            <a:ext cx="12188952" cy="5062776"/>
+          </a:xfrm>
+          <a:prstGeom prst="rect">
+            <a:avLst/>
+          </a:prstGeom>
+        </p:spPr>
+      </p:pic>
+    </p:spTree>
+  </p:cSld>
+  <p:clrMapOvr>
+    <a:masterClrMapping/>
+  </p:clrMapOvr>
+</p:sld>
+</file>
+
+<file path=ppt/slides/slide5.xml><?xml version="1.0" encoding="utf-8"?>
+<p:sld xmlns:a="http://schemas.openxmlformats.org/drawingml/2006/main" xmlns:p="http://schemas.openxmlformats.org/presentationml/2006/main" xmlns:r="http://schemas.openxmlformats.org/officeDocument/2006/relationships">
+  <p:cSld>
+    <p:spTree>
+      <p:nvGrpSpPr>
+        <p:cNvPr id="1" name=""/>
+        <p:cNvGrpSpPr/>
+        <p:nvPr/>
+      </p:nvGrpSpPr>
+      <p:grpSpPr/>
+      <p:sp>
+        <p:nvSpPr>
+          <p:cNvPr id="2" name="Title 1"/>
+          <p:cNvSpPr>
+            <a:spLocks noGrp="1"/>
+          </p:cNvSpPr>
+          <p:nvPr>
+            <p:ph type="title"/>
+          </p:nvPr>
+        </p:nvSpPr>
+        <p:spPr/>
+        <p:txBody>
+          <a:bodyPr/>
+          <a:lstStyle/>
+          <a:p>
+            <a:r>
+              <a:t>Sorted Full Gantt</a:t>
+            </a:r>
+          </a:p>
+        </p:txBody>
+      </p:sp>
+      <p:pic>
+        <p:nvPicPr>
+          <p:cNvPr id="3" name="Picture 2" descr="image.png"/>
+          <p:cNvPicPr>
+            <a:picLocks noChangeAspect="1"/>
+          </p:cNvPicPr>
+          <p:nvPr/>
+        </p:nvPicPr>
+        <p:blipFill>
+          <a:blip r:embed="rId2"/>
+          <a:stretch>
+            <a:fillRect/>
+          </a:stretch>
+        </p:blipFill>
+        <p:spPr>
+          <a:xfrm>
+            <a:off x="0" y="566928"/>
+            <a:ext cx="4800600" cy="4848278"/>
+          </a:xfrm>
+          <a:prstGeom prst="rect">
+            <a:avLst/>
+          </a:prstGeom>
+        </p:spPr>
+      </p:pic>
+    </p:spTree>
+  </p:cSld>
+  <p:clrMapOvr>
+    <a:masterClrMapping/>
+  </p:clrMapOvr>
+</p:sld>
+</file>
+
+<file path=ppt/slides/slide50.xml><?xml version="1.0" encoding="utf-8"?>
+<p:sld xmlns:a="http://schemas.openxmlformats.org/drawingml/2006/main" xmlns:p="http://schemas.openxmlformats.org/presentationml/2006/main" xmlns:r="http://schemas.openxmlformats.org/officeDocument/2006/relationships">
+  <p:cSld>
+    <p:spTree>
+      <p:nvGrpSpPr>
+        <p:cNvPr id="1" name=""/>
+        <p:cNvGrpSpPr/>
+        <p:nvPr/>
+      </p:nvGrpSpPr>
+      <p:grpSpPr/>
+      <p:sp>
+        <p:nvSpPr>
+          <p:cNvPr id="2" name="Title 1"/>
+          <p:cNvSpPr>
+            <a:spLocks noGrp="1"/>
+          </p:cNvSpPr>
+          <p:nvPr>
+            <p:ph type="title"/>
+          </p:nvPr>
+        </p:nvSpPr>
+        <p:spPr/>
+        <p:txBody>
+          <a:bodyPr/>
+          <a:lstStyle/>
+          <a:p>
+            <a:r>
+              <a:t>Total Capacity at Risk by COD - All Regions</a:t>
+            </a:r>
+          </a:p>
+        </p:txBody>
+      </p:sp>
+      <p:pic>
+        <p:nvPicPr>
+          <p:cNvPr id="3" name="Picture 2" descr="image.png"/>
+          <p:cNvPicPr>
+            <a:picLocks noChangeAspect="1"/>
+          </p:cNvPicPr>
+          <p:nvPr/>
+        </p:nvPicPr>
+        <p:blipFill>
+          <a:blip r:embed="rId2"/>
+          <a:stretch>
+            <a:fillRect/>
+          </a:stretch>
+        </p:blipFill>
+        <p:spPr>
+          <a:xfrm>
+            <a:off x="0" y="566928"/>
+            <a:ext cx="12188952" cy="7604516"/>
+          </a:xfrm>
+          <a:prstGeom prst="rect">
+            <a:avLst/>
+          </a:prstGeom>
+        </p:spPr>
+      </p:pic>
+    </p:spTree>
+  </p:cSld>
+  <p:clrMapOvr>
+    <a:masterClrMapping/>
+  </p:clrMapOvr>
+</p:sld>
+</file>
+
+<file path=ppt/slides/slide51.xml><?xml version="1.0" encoding="utf-8"?>
+<p:sld xmlns:a="http://schemas.openxmlformats.org/drawingml/2006/main" xmlns:p="http://schemas.openxmlformats.org/presentationml/2006/main" xmlns:r="http://schemas.openxmlformats.org/officeDocument/2006/relationships">
+  <p:cSld>
+    <p:spTree>
+      <p:nvGrpSpPr>
+        <p:cNvPr id="1" name=""/>
+        <p:cNvGrpSpPr/>
+        <p:nvPr/>
+      </p:nvGrpSpPr>
+      <p:grpSpPr/>
+      <p:sp>
+        <p:nvSpPr>
+          <p:cNvPr id="2" name="Title 1"/>
+          <p:cNvSpPr>
+            <a:spLocks noGrp="1"/>
+          </p:cNvSpPr>
+          <p:nvPr>
+            <p:ph type="title"/>
+          </p:nvPr>
+        </p:nvSpPr>
+        <p:spPr/>
+        <p:txBody>
+          <a:bodyPr/>
+          <a:lstStyle/>
+          <a:p>
+            <a:r>
+              <a:t>Total Capacity at Risk by COD - NE</a:t>
+            </a:r>
+          </a:p>
+        </p:txBody>
+      </p:sp>
+      <p:pic>
+        <p:nvPicPr>
+          <p:cNvPr id="3" name="Picture 2" descr="image.png"/>
+          <p:cNvPicPr>
+            <a:picLocks noChangeAspect="1"/>
+          </p:cNvPicPr>
+          <p:nvPr/>
+        </p:nvPicPr>
+        <p:blipFill>
+          <a:blip r:embed="rId2"/>
+          <a:stretch>
+            <a:fillRect/>
+          </a:stretch>
+        </p:blipFill>
+        <p:spPr>
+          <a:xfrm>
+            <a:off x="0" y="566928"/>
+            <a:ext cx="12188952" cy="7564066"/>
+          </a:xfrm>
+          <a:prstGeom prst="rect">
+            <a:avLst/>
+          </a:prstGeom>
+        </p:spPr>
+      </p:pic>
+    </p:spTree>
+  </p:cSld>
+  <p:clrMapOvr>
+    <a:masterClrMapping/>
+  </p:clrMapOvr>
+</p:sld>
+</file>
+
+<file path=ppt/slides/slide52.xml><?xml version="1.0" encoding="utf-8"?>
+<p:sld xmlns:a="http://schemas.openxmlformats.org/drawingml/2006/main" xmlns:p="http://schemas.openxmlformats.org/presentationml/2006/main" xmlns:r="http://schemas.openxmlformats.org/officeDocument/2006/relationships">
+  <p:cSld>
+    <p:spTree>
+      <p:nvGrpSpPr>
+        <p:cNvPr id="1" name=""/>
+        <p:cNvGrpSpPr/>
+        <p:nvPr/>
+      </p:nvGrpSpPr>
+      <p:grpSpPr/>
+      <p:sp>
+        <p:nvSpPr>
+          <p:cNvPr id="2" name="Title 1"/>
+          <p:cNvSpPr>
+            <a:spLocks noGrp="1"/>
+          </p:cNvSpPr>
+          <p:nvPr>
+            <p:ph type="title"/>
+          </p:nvPr>
+        </p:nvSpPr>
+        <p:spPr/>
+        <p:txBody>
+          <a:bodyPr/>
+          <a:lstStyle/>
+          <a:p>
+            <a:r>
+              <a:t>Total Capacity at Risk by COD - NY/NJ</a:t>
+            </a:r>
+          </a:p>
+        </p:txBody>
+      </p:sp>
+      <p:pic>
+        <p:nvPicPr>
+          <p:cNvPr id="3" name="Picture 2" descr="image.png"/>
+          <p:cNvPicPr>
+            <a:picLocks noChangeAspect="1"/>
+          </p:cNvPicPr>
+          <p:nvPr/>
+        </p:nvPicPr>
+        <p:blipFill>
+          <a:blip r:embed="rId2"/>
+          <a:stretch>
+            <a:fillRect/>
+          </a:stretch>
+        </p:blipFill>
+        <p:spPr>
+          <a:xfrm>
+            <a:off x="0" y="566928"/>
+            <a:ext cx="12188952" cy="7604516"/>
+          </a:xfrm>
+          <a:prstGeom prst="rect">
+            <a:avLst/>
+          </a:prstGeom>
+        </p:spPr>
+      </p:pic>
+    </p:spTree>
+  </p:cSld>
+  <p:clrMapOvr>
+    <a:masterClrMapping/>
+  </p:clrMapOvr>
+</p:sld>
+</file>
+
+<file path=ppt/slides/slide53.xml><?xml version="1.0" encoding="utf-8"?>
+<p:sld xmlns:a="http://schemas.openxmlformats.org/drawingml/2006/main" xmlns:p="http://schemas.openxmlformats.org/presentationml/2006/main" xmlns:r="http://schemas.openxmlformats.org/officeDocument/2006/relationships">
+  <p:cSld>
+    <p:spTree>
+      <p:nvGrpSpPr>
+        <p:cNvPr id="1" name=""/>
+        <p:cNvGrpSpPr/>
+        <p:nvPr/>
+      </p:nvGrpSpPr>
+      <p:grpSpPr/>
+      <p:sp>
+        <p:nvSpPr>
+          <p:cNvPr id="2" name="Title 1"/>
+          <p:cNvSpPr>
+            <a:spLocks noGrp="1"/>
+          </p:cNvSpPr>
+          <p:nvPr>
+            <p:ph type="title"/>
+          </p:nvPr>
+        </p:nvSpPr>
+        <p:spPr/>
+        <p:txBody>
+          <a:bodyPr/>
+          <a:lstStyle/>
+          <a:p>
+            <a:r>
+              <a:t>Total Capacity at Risk by COD - Mid-Atlantic</a:t>
+            </a:r>
+          </a:p>
+        </p:txBody>
+      </p:sp>
+      <p:pic>
+        <p:nvPicPr>
+          <p:cNvPr id="3" name="Picture 2" descr="image.png"/>
+          <p:cNvPicPr>
+            <a:picLocks noChangeAspect="1"/>
+          </p:cNvPicPr>
+          <p:nvPr/>
+        </p:nvPicPr>
+        <p:blipFill>
+          <a:blip r:embed="rId2"/>
+          <a:stretch>
+            <a:fillRect/>
+          </a:stretch>
+        </p:blipFill>
+        <p:spPr>
+          <a:xfrm>
+            <a:off x="0" y="566928"/>
+            <a:ext cx="12188952" cy="7682113"/>
+          </a:xfrm>
+          <a:prstGeom prst="rect">
+            <a:avLst/>
+          </a:prstGeom>
+        </p:spPr>
+      </p:pic>
+    </p:spTree>
+  </p:cSld>
+  <p:clrMapOvr>
+    <a:masterClrMapping/>
+  </p:clrMapOvr>
+</p:sld>
+</file>
+
+<file path=ppt/slides/slide54.xml><?xml version="1.0" encoding="utf-8"?>
+<p:sld xmlns:a="http://schemas.openxmlformats.org/drawingml/2006/main" xmlns:p="http://schemas.openxmlformats.org/presentationml/2006/main" xmlns:r="http://schemas.openxmlformats.org/officeDocument/2006/relationships">
+  <p:cSld>
+    <p:spTree>
+      <p:nvGrpSpPr>
+        <p:cNvPr id="1" name=""/>
+        <p:cNvGrpSpPr/>
+        <p:nvPr/>
+      </p:nvGrpSpPr>
+      <p:grpSpPr/>
+      <p:sp>
+        <p:nvSpPr>
+          <p:cNvPr id="2" name="Title 1"/>
+          <p:cNvSpPr>
+            <a:spLocks noGrp="1"/>
+          </p:cNvSpPr>
+          <p:nvPr>
+            <p:ph type="title"/>
+          </p:nvPr>
+        </p:nvSpPr>
+        <p:spPr/>
+        <p:txBody>
+          <a:bodyPr/>
+          <a:lstStyle/>
+          <a:p>
+            <a:r>
+              <a:t>Average Delay Heat Map - All Regions</a:t>
+            </a:r>
+          </a:p>
+        </p:txBody>
+      </p:sp>
+      <p:pic>
+        <p:nvPicPr>
+          <p:cNvPr id="3" name="Picture 2" descr="image.png"/>
+          <p:cNvPicPr>
+            <a:picLocks noChangeAspect="1"/>
+          </p:cNvPicPr>
+          <p:nvPr/>
+        </p:nvPicPr>
+        <p:blipFill>
+          <a:blip r:embed="rId2"/>
+          <a:stretch>
+            <a:fillRect/>
+          </a:stretch>
+        </p:blipFill>
+        <p:spPr>
+          <a:xfrm>
+            <a:off x="0" y="566928"/>
+            <a:ext cx="12188952" cy="2186359"/>
+          </a:xfrm>
+          <a:prstGeom prst="rect">
+            <a:avLst/>
+          </a:prstGeom>
+        </p:spPr>
+      </p:pic>
+    </p:spTree>
+  </p:cSld>
+  <p:clrMapOvr>
+    <a:masterClrMapping/>
+  </p:clrMapOvr>
+</p:sld>
+</file>
+
+<file path=ppt/slides/slide55.xml><?xml version="1.0" encoding="utf-8"?>
+<p:sld xmlns:a="http://schemas.openxmlformats.org/drawingml/2006/main" xmlns:p="http://schemas.openxmlformats.org/presentationml/2006/main" xmlns:r="http://schemas.openxmlformats.org/officeDocument/2006/relationships">
+  <p:cSld>
+    <p:spTree>
+      <p:nvGrpSpPr>
+        <p:cNvPr id="1" name=""/>
+        <p:cNvGrpSpPr/>
+        <p:nvPr/>
+      </p:nvGrpSpPr>
+      <p:grpSpPr/>
+      <p:sp>
+        <p:nvSpPr>
+          <p:cNvPr id="2" name="Title 1"/>
+          <p:cNvSpPr>
+            <a:spLocks noGrp="1"/>
+          </p:cNvSpPr>
+          <p:nvPr>
+            <p:ph type="title"/>
+          </p:nvPr>
+        </p:nvSpPr>
+        <p:spPr/>
+        <p:txBody>
+          <a:bodyPr/>
+          <a:lstStyle/>
+          <a:p>
+            <a:r>
+              <a:t>Average Delay Heat Map - NE</a:t>
+            </a:r>
+          </a:p>
+        </p:txBody>
+      </p:sp>
+      <p:pic>
+        <p:nvPicPr>
+          <p:cNvPr id="3" name="Picture 2" descr="image.png"/>
+          <p:cNvPicPr>
+            <a:picLocks noChangeAspect="1"/>
+          </p:cNvPicPr>
+          <p:nvPr/>
+        </p:nvPicPr>
+        <p:blipFill>
+          <a:blip r:embed="rId2"/>
+          <a:stretch>
+            <a:fillRect/>
+          </a:stretch>
+        </p:blipFill>
+        <p:spPr>
+          <a:xfrm>
+            <a:off x="0" y="566928"/>
+            <a:ext cx="12188952" cy="2186359"/>
+          </a:xfrm>
+          <a:prstGeom prst="rect">
+            <a:avLst/>
+          </a:prstGeom>
+        </p:spPr>
+      </p:pic>
+    </p:spTree>
+  </p:cSld>
+  <p:clrMapOvr>
+    <a:masterClrMapping/>
+  </p:clrMapOvr>
+</p:sld>
+</file>
+
+<file path=ppt/slides/slide56.xml><?xml version="1.0" encoding="utf-8"?>
+<p:sld xmlns:a="http://schemas.openxmlformats.org/drawingml/2006/main" xmlns:p="http://schemas.openxmlformats.org/presentationml/2006/main" xmlns:r="http://schemas.openxmlformats.org/officeDocument/2006/relationships">
+  <p:cSld>
+    <p:spTree>
+      <p:nvGrpSpPr>
+        <p:cNvPr id="1" name=""/>
+        <p:cNvGrpSpPr/>
+        <p:nvPr/>
+      </p:nvGrpSpPr>
+      <p:grpSpPr/>
+      <p:sp>
+        <p:nvSpPr>
+          <p:cNvPr id="2" name="Title 1"/>
+          <p:cNvSpPr>
+            <a:spLocks noGrp="1"/>
+          </p:cNvSpPr>
+          <p:nvPr>
+            <p:ph type="title"/>
+          </p:nvPr>
+        </p:nvSpPr>
+        <p:spPr/>
+        <p:txBody>
+          <a:bodyPr/>
+          <a:lstStyle/>
+          <a:p>
+            <a:r>
+              <a:t>Average Delay Heat Map - NY/NJ</a:t>
+            </a:r>
+          </a:p>
+        </p:txBody>
+      </p:sp>
+      <p:pic>
+        <p:nvPicPr>
+          <p:cNvPr id="3" name="Picture 2" descr="image.png"/>
+          <p:cNvPicPr>
+            <a:picLocks noChangeAspect="1"/>
+          </p:cNvPicPr>
+          <p:nvPr/>
+        </p:nvPicPr>
+        <p:blipFill>
+          <a:blip r:embed="rId2"/>
+          <a:stretch>
+            <a:fillRect/>
+          </a:stretch>
+        </p:blipFill>
+        <p:spPr>
+          <a:xfrm>
+            <a:off x="0" y="566928"/>
+            <a:ext cx="12188952" cy="2186359"/>
+          </a:xfrm>
+          <a:prstGeom prst="rect">
+            <a:avLst/>
+          </a:prstGeom>
+        </p:spPr>
+      </p:pic>
+    </p:spTree>
+  </p:cSld>
+  <p:clrMapOvr>
+    <a:masterClrMapping/>
+  </p:clrMapOvr>
+</p:sld>
+</file>
+
+<file path=ppt/slides/slide57.xml><?xml version="1.0" encoding="utf-8"?>
+<p:sld xmlns:a="http://schemas.openxmlformats.org/drawingml/2006/main" xmlns:p="http://schemas.openxmlformats.org/presentationml/2006/main" xmlns:r="http://schemas.openxmlformats.org/officeDocument/2006/relationships">
+  <p:cSld>
+    <p:spTree>
+      <p:nvGrpSpPr>
+        <p:cNvPr id="1" name=""/>
+        <p:cNvGrpSpPr/>
+        <p:nvPr/>
+      </p:nvGrpSpPr>
+      <p:grpSpPr/>
+      <p:sp>
+        <p:nvSpPr>
+          <p:cNvPr id="2" name="Title 1"/>
+          <p:cNvSpPr>
+            <a:spLocks noGrp="1"/>
+          </p:cNvSpPr>
+          <p:nvPr>
+            <p:ph type="title"/>
+          </p:nvPr>
+        </p:nvSpPr>
+        <p:spPr/>
+        <p:txBody>
+          <a:bodyPr/>
+          <a:lstStyle/>
+          <a:p>
+            <a:r>
+              <a:t>Average Delay Heat Map - Mid-Atlantic</a:t>
+            </a:r>
+          </a:p>
+        </p:txBody>
+      </p:sp>
+      <p:pic>
+        <p:nvPicPr>
+          <p:cNvPr id="3" name="Picture 2" descr="image.png"/>
+          <p:cNvPicPr>
+            <a:picLocks noChangeAspect="1"/>
+          </p:cNvPicPr>
+          <p:nvPr/>
+        </p:nvPicPr>
+        <p:blipFill>
+          <a:blip r:embed="rId2"/>
+          <a:stretch>
+            <a:fillRect/>
+          </a:stretch>
+        </p:blipFill>
+        <p:spPr>
+          <a:xfrm>
+            <a:off x="0" y="566928"/>
+            <a:ext cx="12188952" cy="2186359"/>
+          </a:xfrm>
+          <a:prstGeom prst="rect">
+            <a:avLst/>
+          </a:prstGeom>
+        </p:spPr>
+      </p:pic>
+    </p:spTree>
+  </p:cSld>
+  <p:clrMapOvr>
+    <a:masterClrMapping/>
+  </p:clrMapOvr>
+</p:sld>
+</file>
+
+<file path=ppt/slides/slide6.xml><?xml version="1.0" encoding="utf-8"?>
+<p:sld xmlns:a="http://schemas.openxmlformats.org/drawingml/2006/main" xmlns:p="http://schemas.openxmlformats.org/presentationml/2006/main" xmlns:r="http://schemas.openxmlformats.org/officeDocument/2006/relationships">
+  <p:cSld>
+    <p:spTree>
+      <p:nvGrpSpPr>
+        <p:cNvPr id="1" name=""/>
+        <p:cNvGrpSpPr/>
+        <p:nvPr/>
+      </p:nvGrpSpPr>
+      <p:grpSpPr/>
+      <p:sp>
+        <p:nvSpPr>
+          <p:cNvPr id="2" name="Title 1"/>
+          <p:cNvSpPr>
+            <a:spLocks noGrp="1"/>
+          </p:cNvSpPr>
+          <p:nvPr>
+            <p:ph type="title"/>
+          </p:nvPr>
+        </p:nvSpPr>
+        <p:spPr/>
+        <p:txBody>
+          <a:bodyPr/>
+          <a:lstStyle/>
+          <a:p>
+            <a:r>
+              <a:t>New England Gantt</a:t>
+            </a:r>
+          </a:p>
+        </p:txBody>
+      </p:sp>
+      <p:pic>
+        <p:nvPicPr>
+          <p:cNvPr id="3" name="Picture 2" descr="image.png"/>
+          <p:cNvPicPr>
+            <a:picLocks noChangeAspect="1"/>
+          </p:cNvPicPr>
+          <p:nvPr/>
+        </p:nvPicPr>
+        <p:blipFill>
+          <a:blip r:embed="rId2"/>
+          <a:stretch>
+            <a:fillRect/>
+          </a:stretch>
+        </p:blipFill>
+        <p:spPr>
+          <a:xfrm>
+            <a:off x="0" y="566928"/>
+            <a:ext cx="12188952" cy="4186105"/>
+          </a:xfrm>
+          <a:prstGeom prst="rect">
+            <a:avLst/>
+          </a:prstGeom>
+        </p:spPr>
+      </p:pic>
+    </p:spTree>
+  </p:cSld>
+  <p:clrMapOvr>
+    <a:masterClrMapping/>
+  </p:clrMapOvr>
+</p:sld>
+</file>
+
+<file path=ppt/slides/slide7.xml><?xml version="1.0" encoding="utf-8"?>
+<p:sld xmlns:a="http://schemas.openxmlformats.org/drawingml/2006/main" xmlns:p="http://schemas.openxmlformats.org/presentationml/2006/main" xmlns:r="http://schemas.openxmlformats.org/officeDocument/2006/relationships">
+  <p:cSld>
+    <p:spTree>
+      <p:nvGrpSpPr>
+        <p:cNvPr id="1" name=""/>
+        <p:cNvGrpSpPr/>
+        <p:nvPr/>
+      </p:nvGrpSpPr>
+      <p:grpSpPr/>
+      <p:sp>
+        <p:nvSpPr>
+          <p:cNvPr id="2" name="Title 1"/>
+          <p:cNvSpPr>
+            <a:spLocks noGrp="1"/>
+          </p:cNvSpPr>
+          <p:nvPr>
+            <p:ph type="title"/>
+          </p:nvPr>
+        </p:nvSpPr>
+        <p:spPr/>
+        <p:txBody>
+          <a:bodyPr/>
+          <a:lstStyle/>
+          <a:p>
+            <a:r>
+              <a:t>Sorted New England Gantt</a:t>
+            </a:r>
+          </a:p>
+        </p:txBody>
+      </p:sp>
+      <p:pic>
+        <p:nvPicPr>
+          <p:cNvPr id="3" name="Picture 2" descr="image.png"/>
+          <p:cNvPicPr>
+            <a:picLocks noChangeAspect="1"/>
+          </p:cNvPicPr>
+          <p:nvPr/>
+        </p:nvPicPr>
+        <p:blipFill>
+          <a:blip r:embed="rId2"/>
+          <a:stretch>
+            <a:fillRect/>
+          </a:stretch>
+        </p:blipFill>
+        <p:spPr>
+          <a:xfrm>
+            <a:off x="0" y="566928"/>
+            <a:ext cx="12188952" cy="4186105"/>
+          </a:xfrm>
+          <a:prstGeom prst="rect">
+            <a:avLst/>
+          </a:prstGeom>
+        </p:spPr>
+      </p:pic>
+    </p:spTree>
+  </p:cSld>
+  <p:clrMapOvr>
+    <a:masterClrMapping/>
+  </p:clrMapOvr>
+</p:sld>
+</file>
+
+<file path=ppt/slides/slide8.xml><?xml version="1.0" encoding="utf-8"?>
+<p:sld xmlns:a="http://schemas.openxmlformats.org/drawingml/2006/main" xmlns:p="http://schemas.openxmlformats.org/presentationml/2006/main" xmlns:r="http://schemas.openxmlformats.org/officeDocument/2006/relationships">
+  <p:cSld>
+    <p:spTree>
+      <p:nvGrpSpPr>
+        <p:cNvPr id="1" name=""/>
+        <p:cNvGrpSpPr/>
+        <p:nvPr/>
+      </p:nvGrpSpPr>
+      <p:grpSpPr/>
+      <p:sp>
+        <p:nvSpPr>
+          <p:cNvPr id="2" name="Title 1"/>
+          <p:cNvSpPr>
+            <a:spLocks noGrp="1"/>
+          </p:cNvSpPr>
+          <p:nvPr>
+            <p:ph type="title"/>
+          </p:nvPr>
+        </p:nvSpPr>
+        <p:spPr/>
+        <p:txBody>
+          <a:bodyPr/>
+          <a:lstStyle/>
+          <a:p>
+            <a:r>
+              <a:t>Fixed Gantt</a:t>
+            </a:r>
+          </a:p>
+        </p:txBody>
+      </p:sp>
+      <p:pic>
+        <p:nvPicPr>
+          <p:cNvPr id="3" name="Picture 2" descr="image.png"/>
+          <p:cNvPicPr>
+            <a:picLocks noChangeAspect="1"/>
+          </p:cNvPicPr>
+          <p:nvPr/>
+        </p:nvPicPr>
+        <p:blipFill>
+          <a:blip r:embed="rId2"/>
+          <a:stretch>
+            <a:fillRect/>
+          </a:stretch>
+        </p:blipFill>
+        <p:spPr>
+          <a:xfrm>
+            <a:off x="0" y="566928"/>
+            <a:ext cx="12188952" cy="10849756"/>
+          </a:xfrm>
+          <a:prstGeom prst="rect">
+            <a:avLst/>
+          </a:prstGeom>
+        </p:spPr>
+      </p:pic>
+    </p:spTree>
+  </p:cSld>
+  <p:clrMapOvr>
+    <a:masterClrMapping/>
+  </p:clrMapOvr>
+</p:sld>
+</file>
+
+<file path=ppt/slides/slide9.xml><?xml version="1.0" encoding="utf-8"?>
+<p:sld xmlns:a="http://schemas.openxmlformats.org/drawingml/2006/main" xmlns:p="http://schemas.openxmlformats.org/presentationml/2006/main" xmlns:r="http://schemas.openxmlformats.org/officeDocument/2006/relationships">
+  <p:cSld>
+    <p:spTree>
+      <p:nvGrpSpPr>
+        <p:cNvPr id="1" name=""/>
+        <p:cNvGrpSpPr/>
+        <p:nvPr/>
+      </p:nvGrpSpPr>
+      <p:grpSpPr/>
+      <p:sp>
+        <p:nvSpPr>
+          <p:cNvPr id="2" name="Title 1"/>
+          <p:cNvSpPr>
+            <a:spLocks noGrp="1"/>
+          </p:cNvSpPr>
+          <p:nvPr>
+            <p:ph type="title"/>
+          </p:nvPr>
+        </p:nvSpPr>
+        <p:spPr/>
+        <p:txBody>
+          <a:bodyPr/>
+          <a:lstStyle/>
+          <a:p>
+            <a:r>
+              <a:t>Sorted Fixed Gantt</a:t>
+            </a:r>
+          </a:p>
+        </p:txBody>
+      </p:sp>
+      <p:pic>
+        <p:nvPicPr>
+          <p:cNvPr id="3" name="Picture 2" descr="image.png"/>
+          <p:cNvPicPr>
+            <a:picLocks noChangeAspect="1"/>
+          </p:cNvPicPr>
+          <p:nvPr/>
+        </p:nvPicPr>
+        <p:blipFill>
+          <a:blip r:embed="rId2"/>
+          <a:stretch>
+            <a:fillRect/>
+          </a:stretch>
+        </p:blipFill>
+        <p:spPr>
+          <a:xfrm>
+            <a:off x="0" y="566928"/>
+            <a:ext cx="12188952" cy="10849756"/>
           </a:xfrm>
           <a:prstGeom prst="rect">
             <a:avLst/>

</xml_diff>